<commit_message>
docs: add font-embedded PDF export of the IR deck
Vector PDF with Pretendard embedded so the layout renders identically on
any machine; the pptx is refreshed with the same shortened flywheel copy.

Co-Authored-By: Claude Fable 5.1 <noreply@anthropic.com>
Claude-Session: https://claude.ai/code/session_012Ee3VguZr5y69sVjVGj3Sd
</commit_message>
<xml_diff>
--- a/docs/ir/STS_IR_revised.pptx
+++ b/docs/ir/STS_IR_revised.pptx
@@ -17352,7 +17352,7 @@
                 <a:ea typeface="Pretendard" pitchFamily="34" charset="-122"/>
                 <a:cs typeface="Pretendard" pitchFamily="34" charset="-120"/>
               </a:rPr>
-              <a:t>더 많은 콘텐츠 (상품 연결)</a:t>
+              <a:t>더 많은 상품 연결 콘텐츠</a:t>
             </a:r>
             <a:endParaRPr lang="en-US" sz="600" dirty="0"/>
           </a:p>
@@ -17680,7 +17680,7 @@
                 <a:ea typeface="Pretendard" pitchFamily="34" charset="-122"/>
                 <a:cs typeface="Pretendard" pitchFamily="34" charset="-120"/>
               </a:rPr>
-              <a:t>관련성 높은 상품으로 클릭 증가</a:t>
+              <a:t>관련성 높은 상품, 클릭 증가</a:t>
             </a:r>
             <a:endParaRPr lang="en-US" sz="600" dirty="0"/>
           </a:p>
@@ -18008,7 +18008,7 @@
                 <a:ea typeface="Pretendard" pitchFamily="34" charset="-122"/>
                 <a:cs typeface="Pretendard" pitchFamily="34" charset="-120"/>
               </a:rPr>
-              <a:t>더 많은 브랜드가 참여 (협찬·캠페인)</a:t>
+              <a:t>더 많은 브랜드가 참여</a:t>
             </a:r>
             <a:endParaRPr lang="en-US" sz="600" dirty="0"/>
           </a:p>
@@ -18172,7 +18172,7 @@
                 <a:ea typeface="Pretendard" pitchFamily="34" charset="-122"/>
                 <a:cs typeface="Pretendard" pitchFamily="34" charset="-120"/>
               </a:rPr>
-              <a:t>더 정확한 매칭으로 전환율 상승</a:t>
+              <a:t>더 정확한 매칭, 전환율 상승</a:t>
             </a:r>
             <a:endParaRPr lang="en-US" sz="600" dirty="0"/>
           </a:p>

</xml_diff>

<commit_message>
docs: add demo link and Southeast Asia beauty screens to IR deck
Clickable demo links (cover, product, closing slide) point at the live
web demo, and the STS BEAUTY flow screenshot now fills the closing
slide's example card.

Co-Authored-By: Claude Opus 5 <noreply@anthropic.com>
Claude-Session: https://claude.ai/code/session_012Ee3VguZr5y69sVjVGj3Sd
</commit_message>
<xml_diff>
--- a/docs/ir/STS_IR_revised.pptx
+++ b/docs/ir/STS_IR_revised.pptx
@@ -2231,13 +2231,172 @@
       </p:sp>
       <p:sp>
         <p:nvSpPr>
-          <p:cNvPr id="6" name="Text 4"/>
-          <p:cNvSpPr txBox="1"/>
-          <p:nvPr/>
-        </p:nvSpPr>
-        <p:spPr>
-          <a:xfrm>
-            <a:off x="731520" y="5852160"/>
+          <p:cNvPr id="6" name="Shape 4"/>
+          <p:cNvSpPr/>
+          <p:nvPr/>
+        </p:nvSpPr>
+        <p:spPr>
+          <a:xfrm>
+            <a:off x="731520" y="5166360"/>
+            <a:ext cx="3566160" cy="384048"/>
+          </a:xfrm>
+          <a:prstGeom prst="roundRect">
+            <a:avLst>
+              <a:gd name="adj" fmla="val 50000"/>
+            </a:avLst>
+          </a:prstGeom>
+          <a:solidFill>
+            <a:srgbClr val="FF2D78"/>
+          </a:solidFill>
+          <a:ln w="12700">
+            <a:solidFill>
+              <a:srgbClr val="FF2D78"/>
+            </a:solidFill>
+            <a:prstDash val="solid"/>
+          </a:ln>
+        </p:spPr>
+      </p:sp>
+      <p:pic>
+        <p:nvPicPr>
+          <p:cNvPr id="7" name="Image 0" descr="preencoded.png">    </p:cNvPr>
+          <p:cNvPicPr>
+            <a:picLocks noChangeAspect="1"/>
+          </p:cNvPicPr>
+          <p:nvPr/>
+        </p:nvPicPr>
+        <p:blipFill>
+          <a:blip r:embed="rId1"/>
+          <a:stretch>
+            <a:fillRect/>
+          </a:stretch>
+        </p:blipFill>
+        <p:spPr>
+          <a:xfrm>
+            <a:off x="877824" y="5266944"/>
+            <a:ext cx="182880" cy="182880"/>
+          </a:xfrm>
+          <a:prstGeom prst="rect">
+            <a:avLst/>
+          </a:prstGeom>
+        </p:spPr>
+      </p:pic>
+      <p:sp>
+        <p:nvSpPr>
+          <p:cNvPr id="8" name="Text 5">
+            <a:hlinkClick r:id="rIdundefined" tooltip=""/>
+          </p:cNvPr>
+          <p:cNvSpPr txBox="1"/>
+          <p:nvPr/>
+        </p:nvSpPr>
+        <p:spPr>
+          <a:xfrm>
+            <a:off x="1143000" y="5166360"/>
+            <a:ext cx="3017520" cy="384048"/>
+          </a:xfrm>
+          <a:prstGeom prst="rect">
+            <a:avLst/>
+          </a:prstGeom>
+          <a:noFill/>
+          <a:ln/>
+        </p:spPr>
+        <p:txBody>
+          <a:bodyPr wrap="square" lIns="0" tIns="0" rIns="0" bIns="0" rtlCol="0" anchor="ctr"/>
+          <a:lstStyle/>
+          <a:p>
+            <a:pPr indent="0" marL="0">
+              <a:buNone/>
+            </a:pPr>
+            <a:r>
+              <a:rPr lang="en-US" sz="850" b="1" u="sng" dirty="0">
+                <a:solidFill>
+                  <a:srgbClr val="FFFFFF"/>
+                </a:solidFill>
+                <a:latin typeface="Pretendard" pitchFamily="34" charset="0"/>
+                <a:ea typeface="Pretendard" pitchFamily="34" charset="-122"/>
+                <a:cs typeface="Pretendard" pitchFamily="34" charset="-120"/>
+                <a:hlinkClick r:id="rIdundefined" invalidUrl="" action="" tgtFrame="" tooltip="" history="1" highlightClick="0" endSnd="0">
+                  <a:extLst>
+                    <a:ext uri="{A12FA001-AC4F-418D-AE19-62706E023703}">
+                      <ahyp:hlinkClr xmlns:ahyp="http://schemas.microsoft.com/office/drawing/2018/hyperlinkcolor" val="tx"/>
+                    </a:ext>
+                  </a:extLst>
+                </a:hlinkClick>
+              </a:rPr>
+              <a:t>데모 바로 보기  </a:t>
+            </a:r>
+            <a:pPr indent="0" marL="0">
+              <a:buNone/>
+            </a:pPr>
+            <a:r>
+              <a:rPr lang="en-US" sz="850" u="sng" dirty="0">
+                <a:solidFill>
+                  <a:srgbClr val="FFFFFF"/>
+                </a:solidFill>
+                <a:latin typeface="Pretendard" pitchFamily="34" charset="0"/>
+                <a:ea typeface="Pretendard" pitchFamily="34" charset="-122"/>
+                <a:cs typeface="Pretendard" pitchFamily="34" charset="-120"/>
+                <a:hlinkClick r:id="rIdundefined" invalidUrl="" action="" tgtFrame="" tooltip="" history="1" highlightClick="0" endSnd="0">
+                  <a:extLst>
+                    <a:ext uri="{A12FA001-AC4F-418D-AE19-62706E023703}">
+                      <ahyp:hlinkClr xmlns:ahyp="http://schemas.microsoft.com/office/drawing/2018/hyperlinkcolor" val="tx"/>
+                    </a:ext>
+                  </a:extLst>
+                </a:hlinkClick>
+              </a:rPr>
+              <a:t>sts-mongben.vercel.app</a:t>
+            </a:r>
+            <a:endParaRPr lang="en-US" sz="850" dirty="0"/>
+          </a:p>
+        </p:txBody>
+      </p:sp>
+      <p:sp>
+        <p:nvSpPr>
+          <p:cNvPr id="9" name="Text 6"/>
+          <p:cNvSpPr txBox="1"/>
+          <p:nvPr/>
+        </p:nvSpPr>
+        <p:spPr>
+          <a:xfrm>
+            <a:off x="731520" y="5632704"/>
+            <a:ext cx="4572000" cy="182880"/>
+          </a:xfrm>
+          <a:prstGeom prst="rect">
+            <a:avLst/>
+          </a:prstGeom>
+          <a:noFill/>
+          <a:ln/>
+        </p:spPr>
+        <p:txBody>
+          <a:bodyPr wrap="square" lIns="0" tIns="0" rIns="0" bIns="0" rtlCol="0" anchor="t"/>
+          <a:lstStyle/>
+          <a:p>
+            <a:pPr indent="0" marL="0">
+              <a:buNone/>
+            </a:pPr>
+            <a:r>
+              <a:rPr lang="en-US" sz="800" dirty="0">
+                <a:solidFill>
+                  <a:srgbClr val="A0A0A8"/>
+                </a:solidFill>
+                <a:latin typeface="Pretendard" pitchFamily="34" charset="0"/>
+                <a:ea typeface="Pretendard" pitchFamily="34" charset="-122"/>
+                <a:cs typeface="Pretendard" pitchFamily="34" charset="-120"/>
+              </a:rPr>
+              <a:t>실제 동작하는 웹 데모에서 태그와 구매 연결을 직접 눌러 볼 수 있습니다.</a:t>
+            </a:r>
+            <a:endParaRPr lang="en-US" sz="800" dirty="0"/>
+          </a:p>
+        </p:txBody>
+      </p:sp>
+      <p:sp>
+        <p:nvSpPr>
+          <p:cNvPr id="10" name="Text 7"/>
+          <p:cNvSpPr txBox="1"/>
+          <p:nvPr/>
+        </p:nvSpPr>
+        <p:spPr>
+          <a:xfrm>
+            <a:off x="731520" y="5943600"/>
             <a:ext cx="3657600" cy="182880"/>
           </a:xfrm>
           <a:prstGeom prst="rect">
@@ -2270,7 +2429,7 @@
       </p:sp>
       <p:sp>
         <p:nvSpPr>
-          <p:cNvPr id="7" name="Shape 5"/>
+          <p:cNvPr id="11" name="Shape 8"/>
           <p:cNvSpPr/>
           <p:nvPr/>
         </p:nvSpPr>
@@ -2297,14 +2456,14 @@
       </p:sp>
       <p:pic>
         <p:nvPicPr>
-          <p:cNvPr id="8" name="Image 0" descr="img/hero_tag.png">    </p:cNvPr>
+          <p:cNvPr id="12" name="Image 1" descr="img/hero_tag.png">    </p:cNvPr>
           <p:cNvPicPr>
             <a:picLocks noChangeAspect="1"/>
           </p:cNvPicPr>
           <p:nvPr/>
         </p:nvPicPr>
         <p:blipFill>
-          <a:blip r:embed="rId1"/>
+          <a:blip r:embed="rId2"/>
           <a:stretch>
             <a:fillRect/>
           </a:stretch>
@@ -2321,7 +2480,7 @@
       </p:pic>
       <p:sp>
         <p:nvSpPr>
-          <p:cNvPr id="9" name="Text 6"/>
+          <p:cNvPr id="13" name="Text 9"/>
           <p:cNvSpPr txBox="1"/>
           <p:nvPr/>
         </p:nvSpPr>
@@ -2360,7 +2519,7 @@
       </p:sp>
       <p:sp>
         <p:nvSpPr>
-          <p:cNvPr id="10" name="Shape 7"/>
+          <p:cNvPr id="14" name="Shape 10"/>
           <p:cNvSpPr/>
           <p:nvPr/>
         </p:nvSpPr>
@@ -2383,7 +2542,7 @@
       </p:sp>
       <p:sp>
         <p:nvSpPr>
-          <p:cNvPr id="11" name="Shape 8"/>
+          <p:cNvPr id="15" name="Shape 11"/>
           <p:cNvSpPr/>
           <p:nvPr/>
         </p:nvSpPr>
@@ -2417,14 +2576,14 @@
       </p:sp>
       <p:pic>
         <p:nvPicPr>
-          <p:cNvPr id="12" name="Image 1" descr="img/thumb_shirt.png">    </p:cNvPr>
+          <p:cNvPr id="16" name="Image 2" descr="img/thumb_shirt.png">    </p:cNvPr>
           <p:cNvPicPr>
             <a:picLocks noChangeAspect="1"/>
           </p:cNvPicPr>
           <p:nvPr/>
         </p:nvPicPr>
         <p:blipFill>
-          <a:blip r:embed="rId2"/>
+          <a:blip r:embed="rId3"/>
           <a:stretch>
             <a:fillRect/>
           </a:stretch>
@@ -2441,7 +2600,7 @@
       </p:pic>
       <p:sp>
         <p:nvSpPr>
-          <p:cNvPr id="13" name="Text 9"/>
+          <p:cNvPr id="17" name="Text 12"/>
           <p:cNvSpPr txBox="1"/>
           <p:nvPr/>
         </p:nvSpPr>
@@ -2480,7 +2639,7 @@
       </p:sp>
       <p:sp>
         <p:nvSpPr>
-          <p:cNvPr id="14" name="Text 10"/>
+          <p:cNvPr id="18" name="Text 13"/>
           <p:cNvSpPr txBox="1"/>
           <p:nvPr/>
         </p:nvSpPr>
@@ -2519,7 +2678,7 @@
       </p:sp>
       <p:sp>
         <p:nvSpPr>
-          <p:cNvPr id="15" name="Text 11"/>
+          <p:cNvPr id="19" name="Text 14"/>
           <p:cNvSpPr txBox="1"/>
           <p:nvPr/>
         </p:nvSpPr>
@@ -2558,7 +2717,7 @@
       </p:sp>
       <p:sp>
         <p:nvSpPr>
-          <p:cNvPr id="16" name="Shape 12"/>
+          <p:cNvPr id="20" name="Shape 15"/>
           <p:cNvSpPr/>
           <p:nvPr/>
         </p:nvSpPr>
@@ -2585,7 +2744,7 @@
       </p:sp>
       <p:sp>
         <p:nvSpPr>
-          <p:cNvPr id="17" name="Text 13"/>
+          <p:cNvPr id="21" name="Text 16"/>
           <p:cNvSpPr txBox="1"/>
           <p:nvPr/>
         </p:nvSpPr>
@@ -2624,7 +2783,7 @@
       </p:sp>
       <p:sp>
         <p:nvSpPr>
-          <p:cNvPr id="18" name="Text 14"/>
+          <p:cNvPr id="22" name="Text 17"/>
           <p:cNvSpPr txBox="1"/>
           <p:nvPr/>
         </p:nvSpPr>
@@ -2663,7 +2822,7 @@
       </p:sp>
       <p:sp>
         <p:nvSpPr>
-          <p:cNvPr id="19" name="Shape 15"/>
+          <p:cNvPr id="23" name="Shape 18"/>
           <p:cNvSpPr/>
           <p:nvPr/>
         </p:nvSpPr>
@@ -2686,7 +2845,7 @@
       </p:sp>
       <p:sp>
         <p:nvSpPr>
-          <p:cNvPr id="20" name="Text 16"/>
+          <p:cNvPr id="24" name="Text 19"/>
           <p:cNvSpPr txBox="1"/>
           <p:nvPr/>
         </p:nvSpPr>
@@ -2725,7 +2884,7 @@
       </p:sp>
       <p:sp>
         <p:nvSpPr>
-          <p:cNvPr id="21" name="Text 17"/>
+          <p:cNvPr id="25" name="Text 20"/>
           <p:cNvSpPr txBox="1"/>
           <p:nvPr/>
         </p:nvSpPr>
@@ -2764,7 +2923,7 @@
       </p:sp>
       <p:sp>
         <p:nvSpPr>
-          <p:cNvPr id="22" name="Text 18"/>
+          <p:cNvPr id="26" name="Text 21"/>
           <p:cNvSpPr txBox="1"/>
           <p:nvPr/>
         </p:nvSpPr>
@@ -10304,7 +10463,7 @@
         </p:nvSpPr>
         <p:spPr>
           <a:xfrm>
-            <a:off x="548640" y="2121408"/>
+            <a:off x="548640" y="2029968"/>
             <a:ext cx="384048" cy="384048"/>
           </a:xfrm>
           <a:prstGeom prst="ellipse">
@@ -10337,7 +10496,7 @@
         </p:blipFill>
         <p:spPr>
           <a:xfrm>
-            <a:off x="644652" y="2217420"/>
+            <a:off x="644652" y="2125980"/>
             <a:ext cx="192024" cy="192024"/>
           </a:xfrm>
           <a:prstGeom prst="rect">
@@ -10353,7 +10512,7 @@
         </p:nvSpPr>
         <p:spPr>
           <a:xfrm>
-            <a:off x="1078992" y="2103120"/>
+            <a:off x="1078992" y="2011680"/>
             <a:ext cx="4681728" cy="228600"/>
           </a:xfrm>
           <a:prstGeom prst="rect">
@@ -10392,8 +10551,8 @@
         </p:nvSpPr>
         <p:spPr>
           <a:xfrm>
-            <a:off x="1078992" y="2340864"/>
-            <a:ext cx="4681728" cy="548640"/>
+            <a:off x="1078992" y="2249424"/>
+            <a:ext cx="4681728" cy="512064"/>
           </a:xfrm>
           <a:prstGeom prst="rect">
             <a:avLst/>
@@ -10434,7 +10593,7 @@
         </p:nvSpPr>
         <p:spPr>
           <a:xfrm>
-            <a:off x="548640" y="2944368"/>
+            <a:off x="548640" y="2779776"/>
             <a:ext cx="384048" cy="384048"/>
           </a:xfrm>
           <a:prstGeom prst="ellipse">
@@ -10467,7 +10626,7 @@
         </p:blipFill>
         <p:spPr>
           <a:xfrm>
-            <a:off x="644652" y="3040380"/>
+            <a:off x="644652" y="2875788"/>
             <a:ext cx="192024" cy="192024"/>
           </a:xfrm>
           <a:prstGeom prst="rect">
@@ -10483,7 +10642,7 @@
         </p:nvSpPr>
         <p:spPr>
           <a:xfrm>
-            <a:off x="1078992" y="2926080"/>
+            <a:off x="1078992" y="2761488"/>
             <a:ext cx="4681728" cy="228600"/>
           </a:xfrm>
           <a:prstGeom prst="rect">
@@ -10522,8 +10681,8 @@
         </p:nvSpPr>
         <p:spPr>
           <a:xfrm>
-            <a:off x="1078992" y="3163824"/>
-            <a:ext cx="4681728" cy="548640"/>
+            <a:off x="1078992" y="2999232"/>
+            <a:ext cx="4681728" cy="512064"/>
           </a:xfrm>
           <a:prstGeom prst="rect">
             <a:avLst/>
@@ -10564,7 +10723,7 @@
         </p:nvSpPr>
         <p:spPr>
           <a:xfrm>
-            <a:off x="548640" y="3767328"/>
+            <a:off x="548640" y="3529584"/>
             <a:ext cx="384048" cy="384048"/>
           </a:xfrm>
           <a:prstGeom prst="ellipse">
@@ -10597,7 +10756,7 @@
         </p:blipFill>
         <p:spPr>
           <a:xfrm>
-            <a:off x="644652" y="3863340"/>
+            <a:off x="644652" y="3625596"/>
             <a:ext cx="192024" cy="192024"/>
           </a:xfrm>
           <a:prstGeom prst="rect">
@@ -10613,47 +10772,47 @@
         </p:nvSpPr>
         <p:spPr>
           <a:xfrm>
+            <a:off x="1078992" y="3511296"/>
+            <a:ext cx="4681728" cy="228600"/>
+          </a:xfrm>
+          <a:prstGeom prst="rect">
+            <a:avLst/>
+          </a:prstGeom>
+          <a:noFill/>
+          <a:ln/>
+        </p:spPr>
+        <p:txBody>
+          <a:bodyPr wrap="square" lIns="0" tIns="0" rIns="0" bIns="0" rtlCol="0" anchor="t"/>
+          <a:lstStyle/>
+          <a:p>
+            <a:pPr indent="0" marL="0">
+              <a:buNone/>
+            </a:pPr>
+            <a:r>
+              <a:rPr lang="en-US" sz="1000" b="1" dirty="0">
+                <a:solidFill>
+                  <a:srgbClr val="1A1A1E"/>
+                </a:solidFill>
+                <a:latin typeface="Pretendard" pitchFamily="34" charset="0"/>
+                <a:ea typeface="Pretendard" pitchFamily="34" charset="-122"/>
+                <a:cs typeface="Pretendard" pitchFamily="34" charset="-120"/>
+              </a:rPr>
+              <a:t>3. 소형 K-뷰티 브랜드의 노출 공백</a:t>
+            </a:r>
+            <a:endParaRPr lang="en-US" sz="1000" dirty="0"/>
+          </a:p>
+        </p:txBody>
+      </p:sp>
+      <p:sp>
+        <p:nvSpPr>
+          <p:cNvPr id="21" name="Text 16"/>
+          <p:cNvSpPr txBox="1"/>
+          <p:nvPr/>
+        </p:nvSpPr>
+        <p:spPr>
+          <a:xfrm>
             <a:off x="1078992" y="3749040"/>
-            <a:ext cx="4681728" cy="228600"/>
-          </a:xfrm>
-          <a:prstGeom prst="rect">
-            <a:avLst/>
-          </a:prstGeom>
-          <a:noFill/>
-          <a:ln/>
-        </p:spPr>
-        <p:txBody>
-          <a:bodyPr wrap="square" lIns="0" tIns="0" rIns="0" bIns="0" rtlCol="0" anchor="t"/>
-          <a:lstStyle/>
-          <a:p>
-            <a:pPr indent="0" marL="0">
-              <a:buNone/>
-            </a:pPr>
-            <a:r>
-              <a:rPr lang="en-US" sz="1000" b="1" dirty="0">
-                <a:solidFill>
-                  <a:srgbClr val="1A1A1E"/>
-                </a:solidFill>
-                <a:latin typeface="Pretendard" pitchFamily="34" charset="0"/>
-                <a:ea typeface="Pretendard" pitchFamily="34" charset="-122"/>
-                <a:cs typeface="Pretendard" pitchFamily="34" charset="-120"/>
-              </a:rPr>
-              <a:t>3. 소형 K-뷰티 브랜드의 노출 공백</a:t>
-            </a:r>
-            <a:endParaRPr lang="en-US" sz="1000" dirty="0"/>
-          </a:p>
-        </p:txBody>
-      </p:sp>
-      <p:sp>
-        <p:nvSpPr>
-          <p:cNvPr id="21" name="Text 16"/>
-          <p:cNvSpPr txBox="1"/>
-          <p:nvPr/>
-        </p:nvSpPr>
-        <p:spPr>
-          <a:xfrm>
-            <a:off x="1078992" y="3986784"/>
-            <a:ext cx="4681728" cy="548640"/>
+            <a:ext cx="4681728" cy="512064"/>
           </a:xfrm>
           <a:prstGeom prst="rect">
             <a:avLst/>
@@ -10694,7 +10853,7 @@
         </p:nvSpPr>
         <p:spPr>
           <a:xfrm>
-            <a:off x="548640" y="4590288"/>
+            <a:off x="548640" y="4279392"/>
             <a:ext cx="384048" cy="384048"/>
           </a:xfrm>
           <a:prstGeom prst="ellipse">
@@ -10727,7 +10886,7 @@
         </p:blipFill>
         <p:spPr>
           <a:xfrm>
-            <a:off x="644652" y="4686300"/>
+            <a:off x="644652" y="4375404"/>
             <a:ext cx="192024" cy="192024"/>
           </a:xfrm>
           <a:prstGeom prst="rect">
@@ -10743,7 +10902,7 @@
         </p:nvSpPr>
         <p:spPr>
           <a:xfrm>
-            <a:off x="1078992" y="4572000"/>
+            <a:off x="1078992" y="4261104"/>
             <a:ext cx="4681728" cy="228600"/>
           </a:xfrm>
           <a:prstGeom prst="rect">
@@ -10782,8 +10941,8 @@
         </p:nvSpPr>
         <p:spPr>
           <a:xfrm>
-            <a:off x="1078992" y="4809744"/>
-            <a:ext cx="4681728" cy="548640"/>
+            <a:off x="1078992" y="4498848"/>
+            <a:ext cx="4681728" cy="512064"/>
           </a:xfrm>
           <a:prstGeom prst="rect">
             <a:avLst/>
@@ -10824,7 +10983,7 @@
         </p:nvSpPr>
         <p:spPr>
           <a:xfrm>
-            <a:off x="548640" y="5413248"/>
+            <a:off x="548640" y="5029200"/>
             <a:ext cx="384048" cy="384048"/>
           </a:xfrm>
           <a:prstGeom prst="ellipse">
@@ -10857,7 +11016,7 @@
         </p:blipFill>
         <p:spPr>
           <a:xfrm>
-            <a:off x="644652" y="5509260"/>
+            <a:off x="644652" y="5125212"/>
             <a:ext cx="192024" cy="192024"/>
           </a:xfrm>
           <a:prstGeom prst="rect">
@@ -10873,7 +11032,7 @@
         </p:nvSpPr>
         <p:spPr>
           <a:xfrm>
-            <a:off x="1078992" y="5394960"/>
+            <a:off x="1078992" y="5010912"/>
             <a:ext cx="4681728" cy="228600"/>
           </a:xfrm>
           <a:prstGeom prst="rect">
@@ -10912,8 +11071,8 @@
         </p:nvSpPr>
         <p:spPr>
           <a:xfrm>
-            <a:off x="1078992" y="5632704"/>
-            <a:ext cx="4681728" cy="548640"/>
+            <a:off x="1078992" y="5248656"/>
+            <a:ext cx="4681728" cy="512064"/>
           </a:xfrm>
           <a:prstGeom prst="rect">
             <a:avLst/>
@@ -10949,6 +11108,165 @@
       <p:sp>
         <p:nvSpPr>
           <p:cNvPr id="30" name="Shape 23"/>
+          <p:cNvSpPr/>
+          <p:nvPr/>
+        </p:nvSpPr>
+        <p:spPr>
+          <a:xfrm>
+            <a:off x="548640" y="5715000"/>
+            <a:ext cx="4023360" cy="384048"/>
+          </a:xfrm>
+          <a:prstGeom prst="roundRect">
+            <a:avLst>
+              <a:gd name="adj" fmla="val 50000"/>
+            </a:avLst>
+          </a:prstGeom>
+          <a:solidFill>
+            <a:srgbClr val="FFFFFF"/>
+          </a:solidFill>
+          <a:ln w="9525">
+            <a:solidFill>
+              <a:srgbClr val="FFC2D8"/>
+            </a:solidFill>
+            <a:prstDash val="solid"/>
+          </a:ln>
+        </p:spPr>
+      </p:sp>
+      <p:pic>
+        <p:nvPicPr>
+          <p:cNvPr id="31" name="Image 5" descr="preencoded.png">    </p:cNvPr>
+          <p:cNvPicPr>
+            <a:picLocks noChangeAspect="1"/>
+          </p:cNvPicPr>
+          <p:nvPr/>
+        </p:nvPicPr>
+        <p:blipFill>
+          <a:blip r:embed="rId6"/>
+          <a:stretch>
+            <a:fillRect/>
+          </a:stretch>
+        </p:blipFill>
+        <p:spPr>
+          <a:xfrm>
+            <a:off x="694944" y="5815584"/>
+            <a:ext cx="182880" cy="182880"/>
+          </a:xfrm>
+          <a:prstGeom prst="rect">
+            <a:avLst/>
+          </a:prstGeom>
+        </p:spPr>
+      </p:pic>
+      <p:sp>
+        <p:nvSpPr>
+          <p:cNvPr id="32" name="Text 24">
+            <a:hlinkClick r:id="rIdundefined" tooltip=""/>
+          </p:cNvPr>
+          <p:cNvSpPr txBox="1"/>
+          <p:nvPr/>
+        </p:nvSpPr>
+        <p:spPr>
+          <a:xfrm>
+            <a:off x="960120" y="5715000"/>
+            <a:ext cx="3474720" cy="384048"/>
+          </a:xfrm>
+          <a:prstGeom prst="rect">
+            <a:avLst/>
+          </a:prstGeom>
+          <a:noFill/>
+          <a:ln/>
+        </p:spPr>
+        <p:txBody>
+          <a:bodyPr wrap="square" lIns="0" tIns="0" rIns="0" bIns="0" rtlCol="0" anchor="ctr"/>
+          <a:lstStyle/>
+          <a:p>
+            <a:pPr indent="0" marL="0">
+              <a:buNone/>
+            </a:pPr>
+            <a:r>
+              <a:rPr lang="en-US" sz="850" b="1" u="sng" dirty="0">
+                <a:solidFill>
+                  <a:srgbClr val="FF2D78"/>
+                </a:solidFill>
+                <a:latin typeface="Pretendard" pitchFamily="34" charset="0"/>
+                <a:ea typeface="Pretendard" pitchFamily="34" charset="-122"/>
+                <a:cs typeface="Pretendard" pitchFamily="34" charset="-120"/>
+                <a:hlinkClick r:id="rIdundefined" invalidUrl="" action="" tgtFrame="" tooltip="" history="1" highlightClick="0" endSnd="0">
+                  <a:extLst>
+                    <a:ext uri="{A12FA001-AC4F-418D-AE19-62706E023703}">
+                      <ahyp:hlinkClr xmlns:ahyp="http://schemas.microsoft.com/office/drawing/2018/hyperlinkcolor" val="tx"/>
+                    </a:ext>
+                  </a:extLst>
+                </a:hlinkClick>
+              </a:rPr>
+              <a:t>데모 바로 보기  </a:t>
+            </a:r>
+            <a:pPr indent="0" marL="0">
+              <a:buNone/>
+            </a:pPr>
+            <a:r>
+              <a:rPr lang="en-US" sz="850" u="sng" dirty="0">
+                <a:solidFill>
+                  <a:srgbClr val="1A1A1E"/>
+                </a:solidFill>
+                <a:latin typeface="Pretendard" pitchFamily="34" charset="0"/>
+                <a:ea typeface="Pretendard" pitchFamily="34" charset="-122"/>
+                <a:cs typeface="Pretendard" pitchFamily="34" charset="-120"/>
+                <a:hlinkClick r:id="rIdundefined" invalidUrl="" action="" tgtFrame="" tooltip="" history="1" highlightClick="0" endSnd="0">
+                  <a:extLst>
+                    <a:ext uri="{A12FA001-AC4F-418D-AE19-62706E023703}">
+                      <ahyp:hlinkClr xmlns:ahyp="http://schemas.microsoft.com/office/drawing/2018/hyperlinkcolor" val="tx"/>
+                    </a:ext>
+                  </a:extLst>
+                </a:hlinkClick>
+              </a:rPr>
+              <a:t>sts-mongben.vercel.app</a:t>
+            </a:r>
+            <a:endParaRPr lang="en-US" sz="850" dirty="0"/>
+          </a:p>
+        </p:txBody>
+      </p:sp>
+      <p:sp>
+        <p:nvSpPr>
+          <p:cNvPr id="33" name="Text 25"/>
+          <p:cNvSpPr txBox="1"/>
+          <p:nvPr/>
+        </p:nvSpPr>
+        <p:spPr>
+          <a:xfrm>
+            <a:off x="4709160" y="5715000"/>
+            <a:ext cx="1051560" cy="384048"/>
+          </a:xfrm>
+          <a:prstGeom prst="rect">
+            <a:avLst/>
+          </a:prstGeom>
+          <a:noFill/>
+          <a:ln/>
+        </p:spPr>
+        <p:txBody>
+          <a:bodyPr wrap="square" lIns="0" tIns="0" rIns="0" bIns="0" rtlCol="0" anchor="ctr"/>
+          <a:lstStyle/>
+          <a:p>
+            <a:pPr indent="0" marL="0">
+              <a:buNone/>
+            </a:pPr>
+            <a:r>
+              <a:rPr lang="en-US" sz="750" dirty="0">
+                <a:solidFill>
+                  <a:srgbClr val="7A7A82"/>
+                </a:solidFill>
+                <a:latin typeface="Pretendard" pitchFamily="34" charset="0"/>
+                <a:ea typeface="Pretendard" pitchFamily="34" charset="-122"/>
+                <a:cs typeface="Pretendard" pitchFamily="34" charset="-120"/>
+              </a:rPr>
+              <a:t>위 화면 흐름은 웹 데모에서 직접 눌러 볼 수 있습니다.</a:t>
+            </a:r>
+            <a:endParaRPr lang="en-US" sz="750" dirty="0"/>
+          </a:p>
+        </p:txBody>
+      </p:sp>
+      <p:sp>
+        <p:nvSpPr>
+          <p:cNvPr id="34" name="Shape 26"/>
           <p:cNvSpPr/>
           <p:nvPr/>
         </p:nvSpPr>
@@ -10975,13 +11293,13 @@
       </p:sp>
       <p:sp>
         <p:nvSpPr>
-          <p:cNvPr id="31" name="Text 24"/>
-          <p:cNvSpPr txBox="1"/>
-          <p:nvPr/>
-        </p:nvSpPr>
-        <p:spPr>
-          <a:xfrm>
-            <a:off x="6309360" y="2286000"/>
+          <p:cNvPr id="35" name="Text 27"/>
+          <p:cNvSpPr txBox="1"/>
+          <p:nvPr/>
+        </p:nvSpPr>
+        <p:spPr>
+          <a:xfrm>
+            <a:off x="6309360" y="2304288"/>
             <a:ext cx="5102352" cy="182880"/>
           </a:xfrm>
           <a:prstGeom prst="rect">
@@ -11006,668 +11324,36 @@
                 <a:ea typeface="Pretendard" pitchFamily="34" charset="-122"/>
                 <a:cs typeface="Pretendard" pitchFamily="34" charset="-120"/>
               </a:rPr>
-              <a:t>STS BEAUTY  ·  Reveal the Process</a:t>
+              <a:t>STS BEAUTY  ·  동남아 K-뷰티 적용 화면 예시</a:t>
             </a:r>
             <a:endParaRPr lang="en-US" sz="750" dirty="0"/>
           </a:p>
         </p:txBody>
       </p:sp>
-      <p:sp>
-        <p:nvSpPr>
-          <p:cNvPr id="32" name="Text 25"/>
-          <p:cNvSpPr txBox="1"/>
-          <p:nvPr/>
-        </p:nvSpPr>
-        <p:spPr>
-          <a:xfrm>
-            <a:off x="6309360" y="2487168"/>
-            <a:ext cx="5102352" cy="274320"/>
-          </a:xfrm>
-          <a:prstGeom prst="rect">
-            <a:avLst/>
-          </a:prstGeom>
-          <a:noFill/>
-          <a:ln/>
-        </p:spPr>
-        <p:txBody>
-          <a:bodyPr wrap="square" lIns="0" tIns="0" rIns="0" bIns="0" rtlCol="0" anchor="t"/>
-          <a:lstStyle/>
-          <a:p>
-            <a:pPr indent="0" marL="0">
-              <a:buNone/>
-            </a:pPr>
-            <a:r>
-              <a:rPr lang="en-US" sz="800" dirty="0">
-                <a:solidFill>
-                  <a:srgbClr val="7A7A82"/>
-                </a:solidFill>
-                <a:latin typeface="Pretendard" pitchFamily="34" charset="0"/>
-                <a:ea typeface="Pretendard" pitchFamily="34" charset="-122"/>
-                <a:cs typeface="Pretendard" pitchFamily="34" charset="-120"/>
-              </a:rPr>
-              <a:t>완성된 룩에서 궁금한 부위를 터치하면 실제 사용 과정과 제품을 확인하고 바로 구매할 수 있어요.</a:t>
-            </a:r>
-            <a:endParaRPr lang="en-US" sz="800" dirty="0"/>
-          </a:p>
-        </p:txBody>
-      </p:sp>
-      <p:sp>
-        <p:nvSpPr>
-          <p:cNvPr id="33" name="Shape 26"/>
-          <p:cNvSpPr/>
-          <p:nvPr/>
-        </p:nvSpPr>
-        <p:spPr>
-          <a:xfrm>
-            <a:off x="7063740" y="2834640"/>
-            <a:ext cx="3593592" cy="2395728"/>
-          </a:xfrm>
-          <a:prstGeom prst="roundRect">
-            <a:avLst>
-              <a:gd name="adj" fmla="val 3053"/>
-            </a:avLst>
-          </a:prstGeom>
-          <a:solidFill>
-            <a:srgbClr val="F6F6F7"/>
-          </a:solidFill>
-          <a:ln w="9525">
-            <a:solidFill>
-              <a:srgbClr val="E4E4E8"/>
-            </a:solidFill>
-            <a:prstDash val="dash"/>
-          </a:ln>
-        </p:spPr>
-      </p:sp>
-      <p:sp>
-        <p:nvSpPr>
-          <p:cNvPr id="34" name="Text 27"/>
-          <p:cNvSpPr txBox="1"/>
-          <p:nvPr/>
-        </p:nvSpPr>
-        <p:spPr>
-          <a:xfrm>
-            <a:off x="7063740" y="2834640"/>
-            <a:ext cx="3593592" cy="2395728"/>
-          </a:xfrm>
-          <a:prstGeom prst="rect">
-            <a:avLst/>
-          </a:prstGeom>
-          <a:noFill/>
-          <a:ln/>
-        </p:spPr>
-        <p:txBody>
-          <a:bodyPr wrap="square" lIns="0" tIns="0" rIns="0" bIns="0" rtlCol="0" anchor="ctr"/>
-          <a:lstStyle/>
-          <a:p>
-            <a:pPr algn="ctr" indent="0" marL="0">
-              <a:lnSpc>
-                <a:spcPct val="140000"/>
-              </a:lnSpc>
-              <a:buNone/>
-            </a:pPr>
-            <a:r>
-              <a:rPr lang="en-US" sz="800" dirty="0">
-                <a:solidFill>
-                  <a:srgbClr val="A0A0A8"/>
-                </a:solidFill>
-                <a:latin typeface="Pretendard" pitchFamily="34" charset="0"/>
-                <a:ea typeface="Pretendard" pitchFamily="34" charset="-122"/>
-                <a:cs typeface="Pretendard" pitchFamily="34" charset="-120"/>
-              </a:rPr>
-              <a:t>STS BEAUTY 화면 예시 이미지</a:t>
-            </a:r>
-            <a:endParaRPr lang="en-US" sz="800" dirty="0"/>
-          </a:p>
-          <a:p>
-            <a:pPr algn="ctr" indent="0" marL="0">
-              <a:lnSpc>
-                <a:spcPct val="140000"/>
-              </a:lnSpc>
-              <a:buNone/>
-            </a:pPr>
-            <a:r>
-              <a:rPr lang="en-US" sz="800" dirty="0">
-                <a:solidFill>
-                  <a:srgbClr val="A0A0A8"/>
-                </a:solidFill>
-                <a:latin typeface="Pretendard" pitchFamily="34" charset="0"/>
-                <a:ea typeface="Pretendard" pitchFamily="34" charset="-122"/>
-                <a:cs typeface="Pretendard" pitchFamily="34" charset="-120"/>
-              </a:rPr>
-              <a:t>(이미지 파일 전달 시 이 자리에 삽입)</a:t>
-            </a:r>
-            <a:endParaRPr lang="en-US" sz="800" dirty="0"/>
-          </a:p>
-        </p:txBody>
-      </p:sp>
-      <p:sp>
-        <p:nvSpPr>
-          <p:cNvPr id="35" name="Shape 28"/>
-          <p:cNvSpPr/>
-          <p:nvPr/>
-        </p:nvSpPr>
-        <p:spPr>
-          <a:xfrm>
-            <a:off x="7063740" y="5367528"/>
-            <a:ext cx="829818" cy="237744"/>
-          </a:xfrm>
-          <a:prstGeom prst="roundRect">
-            <a:avLst>
-              <a:gd name="adj" fmla="val 50000"/>
-            </a:avLst>
-          </a:prstGeom>
-          <a:solidFill>
-            <a:srgbClr val="EEEEF1"/>
-          </a:solidFill>
-          <a:ln w="12700">
-            <a:solidFill>
-              <a:srgbClr val="EEEEF1"/>
-            </a:solidFill>
-            <a:prstDash val="solid"/>
-          </a:ln>
-        </p:spPr>
-      </p:sp>
-      <p:sp>
-        <p:nvSpPr>
-          <p:cNvPr id="36" name="Text 29"/>
-          <p:cNvSpPr txBox="1"/>
-          <p:nvPr/>
-        </p:nvSpPr>
-        <p:spPr>
-          <a:xfrm>
-            <a:off x="7063740" y="5367528"/>
-            <a:ext cx="829818" cy="237744"/>
-          </a:xfrm>
-          <a:prstGeom prst="rect">
-            <a:avLst/>
-          </a:prstGeom>
-          <a:noFill/>
-          <a:ln/>
-        </p:spPr>
-        <p:txBody>
-          <a:bodyPr wrap="square" lIns="0" tIns="0" rIns="0" bIns="0" rtlCol="0" anchor="ctr"/>
-          <a:lstStyle/>
-          <a:p>
-            <a:pPr algn="ctr" indent="0" marL="0">
-              <a:buNone/>
-            </a:pPr>
-            <a:r>
-              <a:rPr lang="en-US" sz="650" b="1" dirty="0">
-                <a:solidFill>
-                  <a:srgbClr val="3A3A42"/>
-                </a:solidFill>
-                <a:latin typeface="Pretendard" pitchFamily="34" charset="0"/>
-                <a:ea typeface="Pretendard" pitchFamily="34" charset="-122"/>
-                <a:cs typeface="Pretendard" pitchFamily="34" charset="-120"/>
-              </a:rPr>
-              <a:t>1. 피드 · 완성된 룩</a:t>
-            </a:r>
-            <a:endParaRPr lang="en-US" sz="650" dirty="0"/>
-          </a:p>
-        </p:txBody>
-      </p:sp>
-      <p:sp>
-        <p:nvSpPr>
-          <p:cNvPr id="37" name="Shape 30"/>
-          <p:cNvSpPr/>
-          <p:nvPr/>
-        </p:nvSpPr>
-        <p:spPr>
-          <a:xfrm>
-            <a:off x="7984998" y="5367528"/>
-            <a:ext cx="829818" cy="237744"/>
-          </a:xfrm>
-          <a:prstGeom prst="roundRect">
-            <a:avLst>
-              <a:gd name="adj" fmla="val 50000"/>
-            </a:avLst>
-          </a:prstGeom>
-          <a:solidFill>
-            <a:srgbClr val="EEEEF1"/>
-          </a:solidFill>
-          <a:ln w="12700">
-            <a:solidFill>
-              <a:srgbClr val="EEEEF1"/>
-            </a:solidFill>
-            <a:prstDash val="solid"/>
-          </a:ln>
-        </p:spPr>
-      </p:sp>
-      <p:sp>
-        <p:nvSpPr>
-          <p:cNvPr id="38" name="Text 31"/>
-          <p:cNvSpPr txBox="1"/>
-          <p:nvPr/>
-        </p:nvSpPr>
-        <p:spPr>
-          <a:xfrm>
-            <a:off x="7984998" y="5367528"/>
-            <a:ext cx="829818" cy="237744"/>
-          </a:xfrm>
-          <a:prstGeom prst="rect">
-            <a:avLst/>
-          </a:prstGeom>
-          <a:noFill/>
-          <a:ln/>
-        </p:spPr>
-        <p:txBody>
-          <a:bodyPr wrap="square" lIns="0" tIns="0" rIns="0" bIns="0" rtlCol="0" anchor="ctr"/>
-          <a:lstStyle/>
-          <a:p>
-            <a:pPr algn="ctr" indent="0" marL="0">
-              <a:buNone/>
-            </a:pPr>
-            <a:r>
-              <a:rPr lang="en-US" sz="650" b="1" dirty="0">
-                <a:solidFill>
-                  <a:srgbClr val="3A3A42"/>
-                </a:solidFill>
-                <a:latin typeface="Pretendard" pitchFamily="34" charset="0"/>
-                <a:ea typeface="Pretendard" pitchFamily="34" charset="-122"/>
-                <a:cs typeface="Pretendard" pitchFamily="34" charset="-120"/>
-              </a:rPr>
-              <a:t>2. 부위 터치 · 과정 공개</a:t>
-            </a:r>
-            <a:endParaRPr lang="en-US" sz="650" dirty="0"/>
-          </a:p>
-        </p:txBody>
-      </p:sp>
-      <p:sp>
-        <p:nvSpPr>
-          <p:cNvPr id="39" name="Shape 32"/>
-          <p:cNvSpPr/>
-          <p:nvPr/>
-        </p:nvSpPr>
-        <p:spPr>
-          <a:xfrm>
-            <a:off x="8906256" y="5367528"/>
-            <a:ext cx="829818" cy="237744"/>
-          </a:xfrm>
-          <a:prstGeom prst="roundRect">
-            <a:avLst>
-              <a:gd name="adj" fmla="val 50000"/>
-            </a:avLst>
-          </a:prstGeom>
-          <a:solidFill>
-            <a:srgbClr val="EEEEF1"/>
-          </a:solidFill>
-          <a:ln w="12700">
-            <a:solidFill>
-              <a:srgbClr val="EEEEF1"/>
-            </a:solidFill>
-            <a:prstDash val="solid"/>
-          </a:ln>
-        </p:spPr>
-      </p:sp>
-      <p:sp>
-        <p:nvSpPr>
-          <p:cNvPr id="40" name="Text 33"/>
-          <p:cNvSpPr txBox="1"/>
-          <p:nvPr/>
-        </p:nvSpPr>
-        <p:spPr>
-          <a:xfrm>
-            <a:off x="8906256" y="5367528"/>
-            <a:ext cx="829818" cy="237744"/>
-          </a:xfrm>
-          <a:prstGeom prst="rect">
-            <a:avLst/>
-          </a:prstGeom>
-          <a:noFill/>
-          <a:ln/>
-        </p:spPr>
-        <p:txBody>
-          <a:bodyPr wrap="square" lIns="0" tIns="0" rIns="0" bIns="0" rtlCol="0" anchor="ctr"/>
-          <a:lstStyle/>
-          <a:p>
-            <a:pPr algn="ctr" indent="0" marL="0">
-              <a:buNone/>
-            </a:pPr>
-            <a:r>
-              <a:rPr lang="en-US" sz="650" b="1" dirty="0">
-                <a:solidFill>
-                  <a:srgbClr val="3A3A42"/>
-                </a:solidFill>
-                <a:latin typeface="Pretendard" pitchFamily="34" charset="0"/>
-                <a:ea typeface="Pretendard" pitchFamily="34" charset="-122"/>
-                <a:cs typeface="Pretendard" pitchFamily="34" charset="-120"/>
-              </a:rPr>
-              <a:t>3. 타임라인 · 과정 선택</a:t>
-            </a:r>
-            <a:endParaRPr lang="en-US" sz="650" dirty="0"/>
-          </a:p>
-        </p:txBody>
-      </p:sp>
-      <p:sp>
-        <p:nvSpPr>
-          <p:cNvPr id="41" name="Shape 34"/>
-          <p:cNvSpPr/>
-          <p:nvPr/>
-        </p:nvSpPr>
-        <p:spPr>
-          <a:xfrm>
-            <a:off x="9827514" y="5367528"/>
-            <a:ext cx="829818" cy="237744"/>
-          </a:xfrm>
-          <a:prstGeom prst="roundRect">
-            <a:avLst>
-              <a:gd name="adj" fmla="val 50000"/>
-            </a:avLst>
-          </a:prstGeom>
-          <a:solidFill>
-            <a:srgbClr val="EEEEF1"/>
-          </a:solidFill>
-          <a:ln w="12700">
-            <a:solidFill>
-              <a:srgbClr val="EEEEF1"/>
-            </a:solidFill>
-            <a:prstDash val="solid"/>
-          </a:ln>
-        </p:spPr>
-      </p:sp>
-      <p:sp>
-        <p:nvSpPr>
-          <p:cNvPr id="42" name="Text 35"/>
-          <p:cNvSpPr txBox="1"/>
-          <p:nvPr/>
-        </p:nvSpPr>
-        <p:spPr>
-          <a:xfrm>
-            <a:off x="9827514" y="5367528"/>
-            <a:ext cx="829818" cy="237744"/>
-          </a:xfrm>
-          <a:prstGeom prst="rect">
-            <a:avLst/>
-          </a:prstGeom>
-          <a:noFill/>
-          <a:ln/>
-        </p:spPr>
-        <p:txBody>
-          <a:bodyPr wrap="square" lIns="0" tIns="0" rIns="0" bIns="0" rtlCol="0" anchor="ctr"/>
-          <a:lstStyle/>
-          <a:p>
-            <a:pPr algn="ctr" indent="0" marL="0">
-              <a:buNone/>
-            </a:pPr>
-            <a:r>
-              <a:rPr lang="en-US" sz="650" b="1" dirty="0">
-                <a:solidFill>
-                  <a:srgbClr val="3A3A42"/>
-                </a:solidFill>
-                <a:latin typeface="Pretendard" pitchFamily="34" charset="0"/>
-                <a:ea typeface="Pretendard" pitchFamily="34" charset="-122"/>
-                <a:cs typeface="Pretendard" pitchFamily="34" charset="-120"/>
-              </a:rPr>
-              <a:t>4. 과정 시청 + 제품 정보</a:t>
-            </a:r>
-            <a:endParaRPr lang="en-US" sz="650" dirty="0"/>
-          </a:p>
-        </p:txBody>
-      </p:sp>
-      <p:sp>
-        <p:nvSpPr>
-          <p:cNvPr id="43" name="Shape 36"/>
-          <p:cNvSpPr/>
-          <p:nvPr/>
-        </p:nvSpPr>
-        <p:spPr>
-          <a:xfrm>
-            <a:off x="7063740" y="5678424"/>
-            <a:ext cx="829818" cy="237744"/>
-          </a:xfrm>
-          <a:prstGeom prst="roundRect">
-            <a:avLst>
-              <a:gd name="adj" fmla="val 50000"/>
-            </a:avLst>
-          </a:prstGeom>
-          <a:solidFill>
-            <a:srgbClr val="FFEAF2"/>
-          </a:solidFill>
-          <a:ln w="12700">
-            <a:solidFill>
-              <a:srgbClr val="FFEAF2"/>
-            </a:solidFill>
-            <a:prstDash val="solid"/>
-          </a:ln>
-        </p:spPr>
-      </p:sp>
-      <p:sp>
-        <p:nvSpPr>
-          <p:cNvPr id="44" name="Text 37"/>
-          <p:cNvSpPr txBox="1"/>
-          <p:nvPr/>
-        </p:nvSpPr>
-        <p:spPr>
-          <a:xfrm>
-            <a:off x="7063740" y="5678424"/>
-            <a:ext cx="829818" cy="237744"/>
-          </a:xfrm>
-          <a:prstGeom prst="rect">
-            <a:avLst/>
-          </a:prstGeom>
-          <a:noFill/>
-          <a:ln/>
-        </p:spPr>
-        <p:txBody>
-          <a:bodyPr wrap="square" lIns="0" tIns="0" rIns="0" bIns="0" rtlCol="0" anchor="ctr"/>
-          <a:lstStyle/>
-          <a:p>
-            <a:pPr algn="ctr" indent="0" marL="0">
-              <a:buNone/>
-            </a:pPr>
-            <a:r>
-              <a:rPr lang="en-US" sz="650" b="1" dirty="0">
-                <a:solidFill>
-                  <a:srgbClr val="FF2D78"/>
-                </a:solidFill>
-                <a:latin typeface="Pretendard" pitchFamily="34" charset="0"/>
-                <a:ea typeface="Pretendard" pitchFamily="34" charset="-122"/>
-                <a:cs typeface="Pretendard" pitchFamily="34" charset="-120"/>
-              </a:rPr>
-              <a:t>5. 전체 제품 보기</a:t>
-            </a:r>
-            <a:endParaRPr lang="en-US" sz="650" dirty="0"/>
-          </a:p>
-        </p:txBody>
-      </p:sp>
-      <p:sp>
-        <p:nvSpPr>
-          <p:cNvPr id="45" name="Shape 38"/>
-          <p:cNvSpPr/>
-          <p:nvPr/>
-        </p:nvSpPr>
-        <p:spPr>
-          <a:xfrm>
-            <a:off x="7984998" y="5678424"/>
-            <a:ext cx="829818" cy="237744"/>
-          </a:xfrm>
-          <a:prstGeom prst="roundRect">
-            <a:avLst>
-              <a:gd name="adj" fmla="val 50000"/>
-            </a:avLst>
-          </a:prstGeom>
-          <a:solidFill>
-            <a:srgbClr val="FFEAF2"/>
-          </a:solidFill>
-          <a:ln w="12700">
-            <a:solidFill>
-              <a:srgbClr val="FFEAF2"/>
-            </a:solidFill>
-            <a:prstDash val="solid"/>
-          </a:ln>
-        </p:spPr>
-      </p:sp>
-      <p:sp>
-        <p:nvSpPr>
-          <p:cNvPr id="46" name="Text 39"/>
-          <p:cNvSpPr txBox="1"/>
-          <p:nvPr/>
-        </p:nvSpPr>
-        <p:spPr>
-          <a:xfrm>
-            <a:off x="7984998" y="5678424"/>
-            <a:ext cx="829818" cy="237744"/>
-          </a:xfrm>
-          <a:prstGeom prst="rect">
-            <a:avLst/>
-          </a:prstGeom>
-          <a:noFill/>
-          <a:ln/>
-        </p:spPr>
-        <p:txBody>
-          <a:bodyPr wrap="square" lIns="0" tIns="0" rIns="0" bIns="0" rtlCol="0" anchor="ctr"/>
-          <a:lstStyle/>
-          <a:p>
-            <a:pPr algn="ctr" indent="0" marL="0">
-              <a:buNone/>
-            </a:pPr>
-            <a:r>
-              <a:rPr lang="en-US" sz="650" b="1" dirty="0">
-                <a:solidFill>
-                  <a:srgbClr val="FF2D78"/>
-                </a:solidFill>
-                <a:latin typeface="Pretendard" pitchFamily="34" charset="0"/>
-                <a:ea typeface="Pretendard" pitchFamily="34" charset="-122"/>
-                <a:cs typeface="Pretendard" pitchFamily="34" charset="-120"/>
-              </a:rPr>
-              <a:t>6. 루틴 한번에 담기</a:t>
-            </a:r>
-            <a:endParaRPr lang="en-US" sz="650" dirty="0"/>
-          </a:p>
-        </p:txBody>
-      </p:sp>
-      <p:sp>
-        <p:nvSpPr>
-          <p:cNvPr id="47" name="Shape 40"/>
-          <p:cNvSpPr/>
-          <p:nvPr/>
-        </p:nvSpPr>
-        <p:spPr>
-          <a:xfrm>
-            <a:off x="8906256" y="5678424"/>
-            <a:ext cx="829818" cy="237744"/>
-          </a:xfrm>
-          <a:prstGeom prst="roundRect">
-            <a:avLst>
-              <a:gd name="adj" fmla="val 50000"/>
-            </a:avLst>
-          </a:prstGeom>
-          <a:solidFill>
-            <a:srgbClr val="FFEAF2"/>
-          </a:solidFill>
-          <a:ln w="12700">
-            <a:solidFill>
-              <a:srgbClr val="FFEAF2"/>
-            </a:solidFill>
-            <a:prstDash val="solid"/>
-          </a:ln>
-        </p:spPr>
-      </p:sp>
-      <p:sp>
-        <p:nvSpPr>
-          <p:cNvPr id="48" name="Text 41"/>
-          <p:cNvSpPr txBox="1"/>
-          <p:nvPr/>
-        </p:nvSpPr>
-        <p:spPr>
-          <a:xfrm>
-            <a:off x="8906256" y="5678424"/>
-            <a:ext cx="829818" cy="237744"/>
-          </a:xfrm>
-          <a:prstGeom prst="rect">
-            <a:avLst/>
-          </a:prstGeom>
-          <a:noFill/>
-          <a:ln/>
-        </p:spPr>
-        <p:txBody>
-          <a:bodyPr wrap="square" lIns="0" tIns="0" rIns="0" bIns="0" rtlCol="0" anchor="ctr"/>
-          <a:lstStyle/>
-          <a:p>
-            <a:pPr algn="ctr" indent="0" marL="0">
-              <a:buNone/>
-            </a:pPr>
-            <a:r>
-              <a:rPr lang="en-US" sz="650" b="1" dirty="0">
-                <a:solidFill>
-                  <a:srgbClr val="FF2D78"/>
-                </a:solidFill>
-                <a:latin typeface="Pretendard" pitchFamily="34" charset="0"/>
-                <a:ea typeface="Pretendard" pitchFamily="34" charset="-122"/>
-                <a:cs typeface="Pretendard" pitchFamily="34" charset="-120"/>
-              </a:rPr>
-              <a:t>7. 유사 컬러 추천</a:t>
-            </a:r>
-            <a:endParaRPr lang="en-US" sz="650" dirty="0"/>
-          </a:p>
-        </p:txBody>
-      </p:sp>
-      <p:sp>
-        <p:nvSpPr>
-          <p:cNvPr id="49" name="Shape 42"/>
-          <p:cNvSpPr/>
-          <p:nvPr/>
-        </p:nvSpPr>
-        <p:spPr>
-          <a:xfrm>
-            <a:off x="9827514" y="5678424"/>
-            <a:ext cx="829818" cy="237744"/>
-          </a:xfrm>
-          <a:prstGeom prst="roundRect">
-            <a:avLst>
-              <a:gd name="adj" fmla="val 50000"/>
-            </a:avLst>
-          </a:prstGeom>
-          <a:solidFill>
-            <a:srgbClr val="FFEAF2"/>
-          </a:solidFill>
-          <a:ln w="12700">
-            <a:solidFill>
-              <a:srgbClr val="FFEAF2"/>
-            </a:solidFill>
-            <a:prstDash val="solid"/>
-          </a:ln>
-        </p:spPr>
-      </p:sp>
-      <p:sp>
-        <p:nvSpPr>
-          <p:cNvPr id="50" name="Text 43"/>
-          <p:cNvSpPr txBox="1"/>
-          <p:nvPr/>
-        </p:nvSpPr>
-        <p:spPr>
-          <a:xfrm>
-            <a:off x="9827514" y="5678424"/>
-            <a:ext cx="829818" cy="237744"/>
-          </a:xfrm>
-          <a:prstGeom prst="rect">
-            <a:avLst/>
-          </a:prstGeom>
-          <a:noFill/>
-          <a:ln/>
-        </p:spPr>
-        <p:txBody>
-          <a:bodyPr wrap="square" lIns="0" tIns="0" rIns="0" bIns="0" rtlCol="0" anchor="ctr"/>
-          <a:lstStyle/>
-          <a:p>
-            <a:pPr algn="ctr" indent="0" marL="0">
-              <a:buNone/>
-            </a:pPr>
-            <a:r>
-              <a:rPr lang="en-US" sz="650" b="1" dirty="0">
-                <a:solidFill>
-                  <a:srgbClr val="FF2D78"/>
-                </a:solidFill>
-                <a:latin typeface="Pretendard" pitchFamily="34" charset="0"/>
-                <a:ea typeface="Pretendard" pitchFamily="34" charset="-122"/>
-                <a:cs typeface="Pretendard" pitchFamily="34" charset="-120"/>
-              </a:rPr>
-              <a:t>8. 구매 완료 · 수익 정산</a:t>
-            </a:r>
-            <a:endParaRPr lang="en-US" sz="650" dirty="0"/>
-          </a:p>
-        </p:txBody>
-      </p:sp>
+      <p:pic>
+        <p:nvPicPr>
+          <p:cNvPr id="36" name="Image 6" descr="img/sea_example.png">    </p:cNvPr>
+          <p:cNvPicPr>
+            <a:picLocks noChangeAspect="1"/>
+          </p:cNvPicPr>
+          <p:nvPr/>
+        </p:nvPicPr>
+        <p:blipFill>
+          <a:blip r:embed="rId7"/>
+          <a:stretch>
+            <a:fillRect/>
+          </a:stretch>
+        </p:blipFill>
+        <p:spPr>
+          <a:xfrm>
+            <a:off x="6323076" y="2606040"/>
+            <a:ext cx="5074920" cy="3383280"/>
+          </a:xfrm>
+          <a:prstGeom prst="rect">
+            <a:avLst/>
+          </a:prstGeom>
+        </p:spPr>
+      </p:pic>
     </p:spTree>
   </p:cSld>
   <p:clrMapOvr>
@@ -17488,6 +17174,126 @@
         </p:nvSpPr>
         <p:spPr>
           <a:xfrm>
+            <a:off x="8074152" y="658368"/>
+            <a:ext cx="3566160" cy="384048"/>
+          </a:xfrm>
+          <a:prstGeom prst="roundRect">
+            <a:avLst>
+              <a:gd name="adj" fmla="val 50000"/>
+            </a:avLst>
+          </a:prstGeom>
+          <a:solidFill>
+            <a:srgbClr val="FFFFFF"/>
+          </a:solidFill>
+          <a:ln w="9525">
+            <a:solidFill>
+              <a:srgbClr val="FFC2D8"/>
+            </a:solidFill>
+            <a:prstDash val="solid"/>
+          </a:ln>
+        </p:spPr>
+      </p:sp>
+      <p:pic>
+        <p:nvPicPr>
+          <p:cNvPr id="11" name="Image 0" descr="preencoded.png">    </p:cNvPr>
+          <p:cNvPicPr>
+            <a:picLocks noChangeAspect="1"/>
+          </p:cNvPicPr>
+          <p:nvPr/>
+        </p:nvPicPr>
+        <p:blipFill>
+          <a:blip r:embed="rId1"/>
+          <a:stretch>
+            <a:fillRect/>
+          </a:stretch>
+        </p:blipFill>
+        <p:spPr>
+          <a:xfrm>
+            <a:off x="8220456" y="758952"/>
+            <a:ext cx="182880" cy="182880"/>
+          </a:xfrm>
+          <a:prstGeom prst="rect">
+            <a:avLst/>
+          </a:prstGeom>
+        </p:spPr>
+      </p:pic>
+      <p:sp>
+        <p:nvSpPr>
+          <p:cNvPr id="12" name="Text 9">
+            <a:hlinkClick r:id="rIdundefined" tooltip=""/>
+          </p:cNvPr>
+          <p:cNvSpPr txBox="1"/>
+          <p:nvPr/>
+        </p:nvSpPr>
+        <p:spPr>
+          <a:xfrm>
+            <a:off x="8485632" y="658368"/>
+            <a:ext cx="3017520" cy="384048"/>
+          </a:xfrm>
+          <a:prstGeom prst="rect">
+            <a:avLst/>
+          </a:prstGeom>
+          <a:noFill/>
+          <a:ln/>
+        </p:spPr>
+        <p:txBody>
+          <a:bodyPr wrap="square" lIns="0" tIns="0" rIns="0" bIns="0" rtlCol="0" anchor="ctr"/>
+          <a:lstStyle/>
+          <a:p>
+            <a:pPr indent="0" marL="0">
+              <a:buNone/>
+            </a:pPr>
+            <a:r>
+              <a:rPr lang="en-US" sz="850" b="1" u="sng" dirty="0">
+                <a:solidFill>
+                  <a:srgbClr val="FF2D78"/>
+                </a:solidFill>
+                <a:latin typeface="Pretendard" pitchFamily="34" charset="0"/>
+                <a:ea typeface="Pretendard" pitchFamily="34" charset="-122"/>
+                <a:cs typeface="Pretendard" pitchFamily="34" charset="-120"/>
+                <a:hlinkClick r:id="rIdundefined" invalidUrl="" action="" tgtFrame="" tooltip="" history="1" highlightClick="0" endSnd="0">
+                  <a:extLst>
+                    <a:ext uri="{A12FA001-AC4F-418D-AE19-62706E023703}">
+                      <ahyp:hlinkClr xmlns:ahyp="http://schemas.microsoft.com/office/drawing/2018/hyperlinkcolor" val="tx"/>
+                    </a:ext>
+                  </a:extLst>
+                </a:hlinkClick>
+              </a:rPr>
+              <a:t>데모 바로 보기  </a:t>
+            </a:r>
+            <a:pPr indent="0" marL="0">
+              <a:buNone/>
+            </a:pPr>
+            <a:r>
+              <a:rPr lang="en-US" sz="850" u="sng" dirty="0">
+                <a:solidFill>
+                  <a:srgbClr val="1A1A1E"/>
+                </a:solidFill>
+                <a:latin typeface="Pretendard" pitchFamily="34" charset="0"/>
+                <a:ea typeface="Pretendard" pitchFamily="34" charset="-122"/>
+                <a:cs typeface="Pretendard" pitchFamily="34" charset="-120"/>
+                <a:hlinkClick r:id="rIdundefined" invalidUrl="" action="" tgtFrame="" tooltip="" history="1" highlightClick="0" endSnd="0">
+                  <a:extLst>
+                    <a:ext uri="{A12FA001-AC4F-418D-AE19-62706E023703}">
+                      <ahyp:hlinkClr xmlns:ahyp="http://schemas.microsoft.com/office/drawing/2018/hyperlinkcolor" val="tx"/>
+                    </a:ext>
+                  </a:extLst>
+                </a:hlinkClick>
+              </a:rPr>
+              <a:t>sts-mongben.vercel.app</a:t>
+            </a:r>
+            <a:endParaRPr lang="en-US" sz="850" dirty="0"/>
+          </a:p>
+        </p:txBody>
+      </p:sp>
+      <p:sp>
+        <p:nvSpPr>
+          <p:cNvPr id="13" name="Shape 10"/>
+          <p:cNvSpPr/>
+          <p:nvPr/>
+        </p:nvSpPr>
+        <p:spPr>
+          <a:xfrm>
             <a:off x="548640" y="1691640"/>
             <a:ext cx="1691640" cy="1325880"/>
           </a:xfrm>
@@ -17509,7 +17315,7 @@
       </p:sp>
       <p:sp>
         <p:nvSpPr>
-          <p:cNvPr id="11" name="Text 9"/>
+          <p:cNvPr id="14" name="Text 11"/>
           <p:cNvSpPr txBox="1"/>
           <p:nvPr/>
         </p:nvSpPr>
@@ -17548,14 +17354,14 @@
       </p:sp>
       <p:pic>
         <p:nvPicPr>
-          <p:cNvPr id="12" name="Image 0" descr="preencoded.png">    </p:cNvPr>
+          <p:cNvPr id="15" name="Image 1" descr="preencoded.png">    </p:cNvPr>
           <p:cNvPicPr>
             <a:picLocks noChangeAspect="1"/>
           </p:cNvPicPr>
           <p:nvPr/>
         </p:nvPicPr>
         <p:blipFill>
-          <a:blip r:embed="rId1"/>
+          <a:blip r:embed="rId2"/>
           <a:stretch>
             <a:fillRect/>
           </a:stretch>
@@ -17572,7 +17378,7 @@
       </p:pic>
       <p:sp>
         <p:nvSpPr>
-          <p:cNvPr id="13" name="Text 10"/>
+          <p:cNvPr id="16" name="Text 12"/>
           <p:cNvSpPr txBox="1"/>
           <p:nvPr/>
         </p:nvSpPr>
@@ -17611,7 +17417,7 @@
       </p:sp>
       <p:sp>
         <p:nvSpPr>
-          <p:cNvPr id="14" name="Text 11"/>
+          <p:cNvPr id="17" name="Text 13"/>
           <p:cNvSpPr txBox="1"/>
           <p:nvPr/>
         </p:nvSpPr>
@@ -17653,7 +17459,7 @@
       </p:sp>
       <p:sp>
         <p:nvSpPr>
-          <p:cNvPr id="15" name="Text 12"/>
+          <p:cNvPr id="18" name="Text 14"/>
           <p:cNvSpPr txBox="1"/>
           <p:nvPr/>
         </p:nvSpPr>
@@ -17692,7 +17498,7 @@
       </p:sp>
       <p:sp>
         <p:nvSpPr>
-          <p:cNvPr id="16" name="Shape 13"/>
+          <p:cNvPr id="19" name="Shape 15"/>
           <p:cNvSpPr/>
           <p:nvPr/>
         </p:nvSpPr>
@@ -17719,7 +17525,7 @@
       </p:sp>
       <p:sp>
         <p:nvSpPr>
-          <p:cNvPr id="17" name="Text 14"/>
+          <p:cNvPr id="20" name="Text 16"/>
           <p:cNvSpPr txBox="1"/>
           <p:nvPr/>
         </p:nvSpPr>
@@ -17758,14 +17564,14 @@
       </p:sp>
       <p:pic>
         <p:nvPicPr>
-          <p:cNvPr id="18" name="Image 1" descr="preencoded.png">    </p:cNvPr>
+          <p:cNvPr id="21" name="Image 2" descr="preencoded.png">    </p:cNvPr>
           <p:cNvPicPr>
             <a:picLocks noChangeAspect="1"/>
           </p:cNvPicPr>
           <p:nvPr/>
         </p:nvPicPr>
         <p:blipFill>
-          <a:blip r:embed="rId2"/>
+          <a:blip r:embed="rId3"/>
           <a:stretch>
             <a:fillRect/>
           </a:stretch>
@@ -17782,7 +17588,7 @@
       </p:pic>
       <p:sp>
         <p:nvSpPr>
-          <p:cNvPr id="19" name="Text 15"/>
+          <p:cNvPr id="22" name="Text 17"/>
           <p:cNvSpPr txBox="1"/>
           <p:nvPr/>
         </p:nvSpPr>
@@ -17821,7 +17627,7 @@
       </p:sp>
       <p:sp>
         <p:nvSpPr>
-          <p:cNvPr id="20" name="Text 16"/>
+          <p:cNvPr id="23" name="Text 18"/>
           <p:cNvSpPr txBox="1"/>
           <p:nvPr/>
         </p:nvSpPr>
@@ -17863,7 +17669,7 @@
       </p:sp>
       <p:sp>
         <p:nvSpPr>
-          <p:cNvPr id="21" name="Text 17"/>
+          <p:cNvPr id="24" name="Text 19"/>
           <p:cNvSpPr txBox="1"/>
           <p:nvPr/>
         </p:nvSpPr>
@@ -17902,7 +17708,7 @@
       </p:sp>
       <p:sp>
         <p:nvSpPr>
-          <p:cNvPr id="22" name="Shape 18"/>
+          <p:cNvPr id="25" name="Shape 20"/>
           <p:cNvSpPr/>
           <p:nvPr/>
         </p:nvSpPr>
@@ -17929,7 +17735,7 @@
       </p:sp>
       <p:sp>
         <p:nvSpPr>
-          <p:cNvPr id="23" name="Text 19"/>
+          <p:cNvPr id="26" name="Text 21"/>
           <p:cNvSpPr txBox="1"/>
           <p:nvPr/>
         </p:nvSpPr>
@@ -17968,14 +17774,14 @@
       </p:sp>
       <p:pic>
         <p:nvPicPr>
-          <p:cNvPr id="24" name="Image 2" descr="preencoded.png">    </p:cNvPr>
+          <p:cNvPr id="27" name="Image 3" descr="preencoded.png">    </p:cNvPr>
           <p:cNvPicPr>
             <a:picLocks noChangeAspect="1"/>
           </p:cNvPicPr>
           <p:nvPr/>
         </p:nvPicPr>
         <p:blipFill>
-          <a:blip r:embed="rId3"/>
+          <a:blip r:embed="rId4"/>
           <a:stretch>
             <a:fillRect/>
           </a:stretch>
@@ -17992,7 +17798,7 @@
       </p:pic>
       <p:sp>
         <p:nvSpPr>
-          <p:cNvPr id="25" name="Text 20"/>
+          <p:cNvPr id="28" name="Text 22"/>
           <p:cNvSpPr txBox="1"/>
           <p:nvPr/>
         </p:nvSpPr>
@@ -18031,7 +17837,7 @@
       </p:sp>
       <p:sp>
         <p:nvSpPr>
-          <p:cNvPr id="26" name="Text 21"/>
+          <p:cNvPr id="29" name="Text 23"/>
           <p:cNvSpPr txBox="1"/>
           <p:nvPr/>
         </p:nvSpPr>
@@ -18073,7 +17879,7 @@
       </p:sp>
       <p:sp>
         <p:nvSpPr>
-          <p:cNvPr id="27" name="Text 22"/>
+          <p:cNvPr id="30" name="Text 24"/>
           <p:cNvSpPr txBox="1"/>
           <p:nvPr/>
         </p:nvSpPr>
@@ -18112,7 +17918,7 @@
       </p:sp>
       <p:sp>
         <p:nvSpPr>
-          <p:cNvPr id="28" name="Shape 23"/>
+          <p:cNvPr id="31" name="Shape 25"/>
           <p:cNvSpPr/>
           <p:nvPr/>
         </p:nvSpPr>
@@ -18139,7 +17945,7 @@
       </p:sp>
       <p:sp>
         <p:nvSpPr>
-          <p:cNvPr id="29" name="Text 24"/>
+          <p:cNvPr id="32" name="Text 26"/>
           <p:cNvSpPr txBox="1"/>
           <p:nvPr/>
         </p:nvSpPr>
@@ -18178,14 +17984,14 @@
       </p:sp>
       <p:pic>
         <p:nvPicPr>
-          <p:cNvPr id="30" name="Image 3" descr="preencoded.png">    </p:cNvPr>
+          <p:cNvPr id="33" name="Image 4" descr="preencoded.png">    </p:cNvPr>
           <p:cNvPicPr>
             <a:picLocks noChangeAspect="1"/>
           </p:cNvPicPr>
           <p:nvPr/>
         </p:nvPicPr>
         <p:blipFill>
-          <a:blip r:embed="rId4"/>
+          <a:blip r:embed="rId5"/>
           <a:stretch>
             <a:fillRect/>
           </a:stretch>
@@ -18202,7 +18008,7 @@
       </p:pic>
       <p:sp>
         <p:nvSpPr>
-          <p:cNvPr id="31" name="Text 25"/>
+          <p:cNvPr id="34" name="Text 27"/>
           <p:cNvSpPr txBox="1"/>
           <p:nvPr/>
         </p:nvSpPr>
@@ -18241,7 +18047,7 @@
       </p:sp>
       <p:sp>
         <p:nvSpPr>
-          <p:cNvPr id="32" name="Text 26"/>
+          <p:cNvPr id="35" name="Text 28"/>
           <p:cNvSpPr txBox="1"/>
           <p:nvPr/>
         </p:nvSpPr>
@@ -18283,7 +18089,7 @@
       </p:sp>
       <p:sp>
         <p:nvSpPr>
-          <p:cNvPr id="33" name="Text 27"/>
+          <p:cNvPr id="36" name="Text 29"/>
           <p:cNvSpPr txBox="1"/>
           <p:nvPr/>
         </p:nvSpPr>
@@ -18322,7 +18128,7 @@
       </p:sp>
       <p:sp>
         <p:nvSpPr>
-          <p:cNvPr id="34" name="Shape 28"/>
+          <p:cNvPr id="37" name="Shape 30"/>
           <p:cNvSpPr/>
           <p:nvPr/>
         </p:nvSpPr>
@@ -18349,7 +18155,7 @@
       </p:sp>
       <p:sp>
         <p:nvSpPr>
-          <p:cNvPr id="35" name="Text 29"/>
+          <p:cNvPr id="38" name="Text 31"/>
           <p:cNvSpPr txBox="1"/>
           <p:nvPr/>
         </p:nvSpPr>
@@ -18388,14 +18194,14 @@
       </p:sp>
       <p:pic>
         <p:nvPicPr>
-          <p:cNvPr id="36" name="Image 4" descr="preencoded.png">    </p:cNvPr>
+          <p:cNvPr id="39" name="Image 5" descr="preencoded.png">    </p:cNvPr>
           <p:cNvPicPr>
             <a:picLocks noChangeAspect="1"/>
           </p:cNvPicPr>
           <p:nvPr/>
         </p:nvPicPr>
         <p:blipFill>
-          <a:blip r:embed="rId5"/>
+          <a:blip r:embed="rId6"/>
           <a:stretch>
             <a:fillRect/>
           </a:stretch>
@@ -18412,7 +18218,7 @@
       </p:pic>
       <p:sp>
         <p:nvSpPr>
-          <p:cNvPr id="37" name="Text 30"/>
+          <p:cNvPr id="40" name="Text 32"/>
           <p:cNvSpPr txBox="1"/>
           <p:nvPr/>
         </p:nvSpPr>
@@ -18451,7 +18257,7 @@
       </p:sp>
       <p:sp>
         <p:nvSpPr>
-          <p:cNvPr id="38" name="Text 31"/>
+          <p:cNvPr id="41" name="Text 33"/>
           <p:cNvSpPr txBox="1"/>
           <p:nvPr/>
         </p:nvSpPr>
@@ -18493,7 +18299,7 @@
       </p:sp>
       <p:sp>
         <p:nvSpPr>
-          <p:cNvPr id="39" name="Text 32"/>
+          <p:cNvPr id="42" name="Text 34"/>
           <p:cNvSpPr txBox="1"/>
           <p:nvPr/>
         </p:nvSpPr>
@@ -18532,7 +18338,7 @@
       </p:sp>
       <p:sp>
         <p:nvSpPr>
-          <p:cNvPr id="40" name="Shape 33"/>
+          <p:cNvPr id="43" name="Shape 35"/>
           <p:cNvSpPr/>
           <p:nvPr/>
         </p:nvSpPr>
@@ -18559,7 +18365,7 @@
       </p:sp>
       <p:sp>
         <p:nvSpPr>
-          <p:cNvPr id="41" name="Text 34"/>
+          <p:cNvPr id="44" name="Text 36"/>
           <p:cNvSpPr txBox="1"/>
           <p:nvPr/>
         </p:nvSpPr>
@@ -18598,14 +18404,14 @@
       </p:sp>
       <p:pic>
         <p:nvPicPr>
-          <p:cNvPr id="42" name="Image 5" descr="preencoded.png">    </p:cNvPr>
+          <p:cNvPr id="45" name="Image 6" descr="preencoded.png">    </p:cNvPr>
           <p:cNvPicPr>
             <a:picLocks noChangeAspect="1"/>
           </p:cNvPicPr>
           <p:nvPr/>
         </p:nvPicPr>
         <p:blipFill>
-          <a:blip r:embed="rId6"/>
+          <a:blip r:embed="rId7"/>
           <a:stretch>
             <a:fillRect/>
           </a:stretch>
@@ -18622,7 +18428,7 @@
       </p:pic>
       <p:sp>
         <p:nvSpPr>
-          <p:cNvPr id="43" name="Text 35"/>
+          <p:cNvPr id="46" name="Text 37"/>
           <p:cNvSpPr txBox="1"/>
           <p:nvPr/>
         </p:nvSpPr>
@@ -18661,7 +18467,7 @@
       </p:sp>
       <p:sp>
         <p:nvSpPr>
-          <p:cNvPr id="44" name="Text 36"/>
+          <p:cNvPr id="47" name="Text 38"/>
           <p:cNvSpPr txBox="1"/>
           <p:nvPr/>
         </p:nvSpPr>
@@ -18703,7 +18509,7 @@
       </p:sp>
       <p:sp>
         <p:nvSpPr>
-          <p:cNvPr id="45" name="Shape 37"/>
+          <p:cNvPr id="48" name="Shape 39"/>
           <p:cNvSpPr/>
           <p:nvPr/>
         </p:nvSpPr>
@@ -18730,7 +18536,7 @@
       </p:sp>
       <p:sp>
         <p:nvSpPr>
-          <p:cNvPr id="46" name="Text 38"/>
+          <p:cNvPr id="49" name="Text 40"/>
           <p:cNvSpPr txBox="1"/>
           <p:nvPr/>
         </p:nvSpPr>
@@ -18769,7 +18575,7 @@
       </p:sp>
       <p:sp>
         <p:nvSpPr>
-          <p:cNvPr id="47" name="Text 39"/>
+          <p:cNvPr id="50" name="Text 41"/>
           <p:cNvSpPr txBox="1"/>
           <p:nvPr/>
         </p:nvSpPr>
@@ -18808,31 +18614,7 @@
       </p:sp>
       <p:pic>
         <p:nvPicPr>
-          <p:cNvPr id="48" name="Image 6" descr="img/cmp_bbox.png">    </p:cNvPr>
-          <p:cNvPicPr>
-            <a:picLocks noChangeAspect="1"/>
-          </p:cNvPicPr>
-          <p:nvPr/>
-        </p:nvPicPr>
-        <p:blipFill>
-          <a:blip r:embed="rId7"/>
-          <a:stretch>
-            <a:fillRect/>
-          </a:stretch>
-        </p:blipFill>
-        <p:spPr>
-          <a:xfrm>
-            <a:off x="960120" y="3703320"/>
-            <a:ext cx="1965960" cy="1600200"/>
-          </a:xfrm>
-          <a:prstGeom prst="rect">
-            <a:avLst/>
-          </a:prstGeom>
-        </p:spPr>
-      </p:pic>
-      <p:pic>
-        <p:nvPicPr>
-          <p:cNvPr id="49" name="Image 7" descr="img/cmp_poly.png">    </p:cNvPr>
+          <p:cNvPr id="51" name="Image 7" descr="img/cmp_bbox.png">    </p:cNvPr>
           <p:cNvPicPr>
             <a:picLocks noChangeAspect="1"/>
           </p:cNvPicPr>
@@ -18846,7 +18628,7 @@
         </p:blipFill>
         <p:spPr>
           <a:xfrm>
-            <a:off x="3291840" y="3703320"/>
+            <a:off x="960120" y="3703320"/>
             <a:ext cx="1965960" cy="1600200"/>
           </a:xfrm>
           <a:prstGeom prst="rect">
@@ -18854,126 +18636,9 @@
           </a:prstGeom>
         </p:spPr>
       </p:pic>
-      <p:sp>
-        <p:nvSpPr>
-          <p:cNvPr id="50" name="Text 40"/>
-          <p:cNvSpPr txBox="1"/>
-          <p:nvPr/>
-        </p:nvSpPr>
-        <p:spPr>
-          <a:xfrm>
-            <a:off x="960120" y="5349240"/>
-            <a:ext cx="1965960" cy="201168"/>
-          </a:xfrm>
-          <a:prstGeom prst="rect">
-            <a:avLst/>
-          </a:prstGeom>
-          <a:noFill/>
-          <a:ln/>
-        </p:spPr>
-        <p:txBody>
-          <a:bodyPr wrap="square" lIns="0" tIns="0" rIns="0" bIns="0" rtlCol="0" anchor="t"/>
-          <a:lstStyle/>
-          <a:p>
-            <a:pPr algn="ctr" indent="0" marL="0">
-              <a:buNone/>
-            </a:pPr>
-            <a:r>
-              <a:rPr lang="en-US" sz="750" dirty="0">
-                <a:solidFill>
-                  <a:srgbClr val="7A7A82"/>
-                </a:solidFill>
-                <a:latin typeface="Pretendard" pitchFamily="34" charset="0"/>
-                <a:ea typeface="Pretendard" pitchFamily="34" charset="-122"/>
-                <a:cs typeface="Pretendard" pitchFamily="34" charset="-120"/>
-              </a:rPr>
-              <a:t>정확하지 않은 영역</a:t>
-            </a:r>
-            <a:endParaRPr lang="en-US" sz="750" dirty="0"/>
-          </a:p>
-        </p:txBody>
-      </p:sp>
-      <p:sp>
-        <p:nvSpPr>
-          <p:cNvPr id="51" name="Text 41"/>
-          <p:cNvSpPr txBox="1"/>
-          <p:nvPr/>
-        </p:nvSpPr>
-        <p:spPr>
-          <a:xfrm>
-            <a:off x="3291840" y="5349240"/>
-            <a:ext cx="1965960" cy="201168"/>
-          </a:xfrm>
-          <a:prstGeom prst="rect">
-            <a:avLst/>
-          </a:prstGeom>
-          <a:noFill/>
-          <a:ln/>
-        </p:spPr>
-        <p:txBody>
-          <a:bodyPr wrap="square" lIns="0" tIns="0" rIns="0" bIns="0" rtlCol="0" anchor="t"/>
-          <a:lstStyle/>
-          <a:p>
-            <a:pPr algn="ctr" indent="0" marL="0">
-              <a:buNone/>
-            </a:pPr>
-            <a:r>
-              <a:rPr lang="en-US" sz="750" b="1" dirty="0">
-                <a:solidFill>
-                  <a:srgbClr val="FF2D78"/>
-                </a:solidFill>
-                <a:latin typeface="Pretendard" pitchFamily="34" charset="0"/>
-                <a:ea typeface="Pretendard" pitchFamily="34" charset="-122"/>
-                <a:cs typeface="Pretendard" pitchFamily="34" charset="-120"/>
-              </a:rPr>
-              <a:t>실제 상품 모양을 정확히</a:t>
-            </a:r>
-            <a:endParaRPr lang="en-US" sz="750" dirty="0"/>
-          </a:p>
-        </p:txBody>
-      </p:sp>
-      <p:sp>
-        <p:nvSpPr>
-          <p:cNvPr id="52" name="Text 42"/>
-          <p:cNvSpPr txBox="1"/>
-          <p:nvPr/>
-        </p:nvSpPr>
-        <p:spPr>
-          <a:xfrm>
-            <a:off x="6035040" y="3383280"/>
-            <a:ext cx="5486400" cy="274320"/>
-          </a:xfrm>
-          <a:prstGeom prst="rect">
-            <a:avLst/>
-          </a:prstGeom>
-          <a:noFill/>
-          <a:ln/>
-        </p:spPr>
-        <p:txBody>
-          <a:bodyPr wrap="square" lIns="0" tIns="0" rIns="0" bIns="0" rtlCol="0" anchor="t"/>
-          <a:lstStyle/>
-          <a:p>
-            <a:pPr indent="0" marL="0">
-              <a:buNone/>
-            </a:pPr>
-            <a:r>
-              <a:rPr lang="en-US" sz="1200" b="1" dirty="0">
-                <a:solidFill>
-                  <a:srgbClr val="1A1A1E"/>
-                </a:solidFill>
-                <a:latin typeface="Pretendard" pitchFamily="34" charset="0"/>
-                <a:ea typeface="Pretendard" pitchFamily="34" charset="-122"/>
-                <a:cs typeface="Pretendard" pitchFamily="34" charset="-120"/>
-              </a:rPr>
-              <a:t>STS는 실제 상품의 모양을 정확히 구분합니다</a:t>
-            </a:r>
-            <a:endParaRPr lang="en-US" sz="1200" dirty="0"/>
-          </a:p>
-        </p:txBody>
-      </p:sp>
       <p:pic>
         <p:nvPicPr>
-          <p:cNvPr id="53" name="Image 8" descr="preencoded.png">    </p:cNvPr>
+          <p:cNvPr id="52" name="Image 8" descr="img/cmp_poly.png">    </p:cNvPr>
           <p:cNvPicPr>
             <a:picLocks noChangeAspect="1"/>
           </p:cNvPicPr>
@@ -18987,8 +18652,8 @@
         </p:blipFill>
         <p:spPr>
           <a:xfrm>
-            <a:off x="6035040" y="3794760"/>
-            <a:ext cx="146304" cy="146304"/>
+            <a:off x="3291840" y="3703320"/>
+            <a:ext cx="1965960" cy="1600200"/>
           </a:xfrm>
           <a:prstGeom prst="rect">
             <a:avLst/>
@@ -18997,46 +18662,124 @@
       </p:pic>
       <p:sp>
         <p:nvSpPr>
+          <p:cNvPr id="53" name="Text 42"/>
+          <p:cNvSpPr txBox="1"/>
+          <p:nvPr/>
+        </p:nvSpPr>
+        <p:spPr>
+          <a:xfrm>
+            <a:off x="960120" y="5349240"/>
+            <a:ext cx="1965960" cy="201168"/>
+          </a:xfrm>
+          <a:prstGeom prst="rect">
+            <a:avLst/>
+          </a:prstGeom>
+          <a:noFill/>
+          <a:ln/>
+        </p:spPr>
+        <p:txBody>
+          <a:bodyPr wrap="square" lIns="0" tIns="0" rIns="0" bIns="0" rtlCol="0" anchor="t"/>
+          <a:lstStyle/>
+          <a:p>
+            <a:pPr algn="ctr" indent="0" marL="0">
+              <a:buNone/>
+            </a:pPr>
+            <a:r>
+              <a:rPr lang="en-US" sz="750" dirty="0">
+                <a:solidFill>
+                  <a:srgbClr val="7A7A82"/>
+                </a:solidFill>
+                <a:latin typeface="Pretendard" pitchFamily="34" charset="0"/>
+                <a:ea typeface="Pretendard" pitchFamily="34" charset="-122"/>
+                <a:cs typeface="Pretendard" pitchFamily="34" charset="-120"/>
+              </a:rPr>
+              <a:t>정확하지 않은 영역</a:t>
+            </a:r>
+            <a:endParaRPr lang="en-US" sz="750" dirty="0"/>
+          </a:p>
+        </p:txBody>
+      </p:sp>
+      <p:sp>
+        <p:nvSpPr>
           <p:cNvPr id="54" name="Text 43"/>
           <p:cNvSpPr txBox="1"/>
           <p:nvPr/>
         </p:nvSpPr>
         <p:spPr>
           <a:xfrm>
-            <a:off x="6263640" y="3767328"/>
-            <a:ext cx="5376672" cy="365760"/>
-          </a:xfrm>
-          <a:prstGeom prst="rect">
-            <a:avLst/>
-          </a:prstGeom>
-          <a:noFill/>
-          <a:ln/>
-        </p:spPr>
-        <p:txBody>
-          <a:bodyPr wrap="square" lIns="0" tIns="0" rIns="0" bIns="0" rtlCol="0" anchor="t"/>
-          <a:lstStyle/>
-          <a:p>
-            <a:pPr indent="0" marL="0">
-              <a:buNone/>
-            </a:pPr>
-            <a:r>
-              <a:rPr lang="en-US" sz="900" dirty="0">
-                <a:solidFill>
-                  <a:srgbClr val="3A3A42"/>
-                </a:solidFill>
-                <a:latin typeface="Pretendard" pitchFamily="34" charset="0"/>
-                <a:ea typeface="Pretendard" pitchFamily="34" charset="-122"/>
-                <a:cs typeface="Pretendard" pitchFamily="34" charset="-120"/>
-              </a:rPr>
-              <a:t>네모 박스가 아닌, 실제 상품의 실루엣(모양)을 따라 영역을 구분합니다.</a:t>
-            </a:r>
-            <a:endParaRPr lang="en-US" sz="900" dirty="0"/>
+            <a:off x="3291840" y="5349240"/>
+            <a:ext cx="1965960" cy="201168"/>
+          </a:xfrm>
+          <a:prstGeom prst="rect">
+            <a:avLst/>
+          </a:prstGeom>
+          <a:noFill/>
+          <a:ln/>
+        </p:spPr>
+        <p:txBody>
+          <a:bodyPr wrap="square" lIns="0" tIns="0" rIns="0" bIns="0" rtlCol="0" anchor="t"/>
+          <a:lstStyle/>
+          <a:p>
+            <a:pPr algn="ctr" indent="0" marL="0">
+              <a:buNone/>
+            </a:pPr>
+            <a:r>
+              <a:rPr lang="en-US" sz="750" b="1" dirty="0">
+                <a:solidFill>
+                  <a:srgbClr val="FF2D78"/>
+                </a:solidFill>
+                <a:latin typeface="Pretendard" pitchFamily="34" charset="0"/>
+                <a:ea typeface="Pretendard" pitchFamily="34" charset="-122"/>
+                <a:cs typeface="Pretendard" pitchFamily="34" charset="-120"/>
+              </a:rPr>
+              <a:t>실제 상품 모양을 정확히</a:t>
+            </a:r>
+            <a:endParaRPr lang="en-US" sz="750" dirty="0"/>
+          </a:p>
+        </p:txBody>
+      </p:sp>
+      <p:sp>
+        <p:nvSpPr>
+          <p:cNvPr id="55" name="Text 44"/>
+          <p:cNvSpPr txBox="1"/>
+          <p:nvPr/>
+        </p:nvSpPr>
+        <p:spPr>
+          <a:xfrm>
+            <a:off x="6035040" y="3383280"/>
+            <a:ext cx="5486400" cy="274320"/>
+          </a:xfrm>
+          <a:prstGeom prst="rect">
+            <a:avLst/>
+          </a:prstGeom>
+          <a:noFill/>
+          <a:ln/>
+        </p:spPr>
+        <p:txBody>
+          <a:bodyPr wrap="square" lIns="0" tIns="0" rIns="0" bIns="0" rtlCol="0" anchor="t"/>
+          <a:lstStyle/>
+          <a:p>
+            <a:pPr indent="0" marL="0">
+              <a:buNone/>
+            </a:pPr>
+            <a:r>
+              <a:rPr lang="en-US" sz="1200" b="1" dirty="0">
+                <a:solidFill>
+                  <a:srgbClr val="1A1A1E"/>
+                </a:solidFill>
+                <a:latin typeface="Pretendard" pitchFamily="34" charset="0"/>
+                <a:ea typeface="Pretendard" pitchFamily="34" charset="-122"/>
+                <a:cs typeface="Pretendard" pitchFamily="34" charset="-120"/>
+              </a:rPr>
+              <a:t>STS는 실제 상품의 모양을 정확히 구분합니다</a:t>
+            </a:r>
+            <a:endParaRPr lang="en-US" sz="1200" dirty="0"/>
           </a:p>
         </p:txBody>
       </p:sp>
       <p:pic>
         <p:nvPicPr>
-          <p:cNvPr id="55" name="Image 9" descr="preencoded.png">    </p:cNvPr>
+          <p:cNvPr id="56" name="Image 9" descr="preencoded.png">    </p:cNvPr>
           <p:cNvPicPr>
             <a:picLocks noChangeAspect="1"/>
           </p:cNvPicPr>
@@ -19050,7 +18793,7 @@
         </p:blipFill>
         <p:spPr>
           <a:xfrm>
-            <a:off x="6035040" y="4160520"/>
+            <a:off x="6035040" y="3794760"/>
             <a:ext cx="146304" cy="146304"/>
           </a:xfrm>
           <a:prstGeom prst="rect">
@@ -19060,13 +18803,13 @@
       </p:pic>
       <p:sp>
         <p:nvSpPr>
-          <p:cNvPr id="56" name="Text 44"/>
-          <p:cNvSpPr txBox="1"/>
-          <p:nvPr/>
-        </p:nvSpPr>
-        <p:spPr>
-          <a:xfrm>
-            <a:off x="6263640" y="4133088"/>
+          <p:cNvPr id="57" name="Text 45"/>
+          <p:cNvSpPr txBox="1"/>
+          <p:nvPr/>
+        </p:nvSpPr>
+        <p:spPr>
+          <a:xfrm>
+            <a:off x="6263640" y="3767328"/>
             <a:ext cx="5376672" cy="365760"/>
           </a:xfrm>
           <a:prstGeom prst="rect">
@@ -19091,7 +18834,7 @@
                 <a:ea typeface="Pretendard" pitchFamily="34" charset="-122"/>
                 <a:cs typeface="Pretendard" pitchFamily="34" charset="-120"/>
               </a:rPr>
-              <a:t>더 정확한 매칭으로 원하는 상품을 빠르게 찾을 수 있습니다.</a:t>
+              <a:t>네모 박스가 아닌, 실제 상품의 실루엣(모양)을 따라 영역을 구분합니다.</a:t>
             </a:r>
             <a:endParaRPr lang="en-US" sz="900" dirty="0"/>
           </a:p>
@@ -19099,7 +18842,7 @@
       </p:sp>
       <p:pic>
         <p:nvPicPr>
-          <p:cNvPr id="57" name="Image 10" descr="preencoded.png">    </p:cNvPr>
+          <p:cNvPr id="58" name="Image 10" descr="preencoded.png">    </p:cNvPr>
           <p:cNvPicPr>
             <a:picLocks noChangeAspect="1"/>
           </p:cNvPicPr>
@@ -19113,6 +18856,69 @@
         </p:blipFill>
         <p:spPr>
           <a:xfrm>
+            <a:off x="6035040" y="4160520"/>
+            <a:ext cx="146304" cy="146304"/>
+          </a:xfrm>
+          <a:prstGeom prst="rect">
+            <a:avLst/>
+          </a:prstGeom>
+        </p:spPr>
+      </p:pic>
+      <p:sp>
+        <p:nvSpPr>
+          <p:cNvPr id="59" name="Text 46"/>
+          <p:cNvSpPr txBox="1"/>
+          <p:nvPr/>
+        </p:nvSpPr>
+        <p:spPr>
+          <a:xfrm>
+            <a:off x="6263640" y="4133088"/>
+            <a:ext cx="5376672" cy="365760"/>
+          </a:xfrm>
+          <a:prstGeom prst="rect">
+            <a:avLst/>
+          </a:prstGeom>
+          <a:noFill/>
+          <a:ln/>
+        </p:spPr>
+        <p:txBody>
+          <a:bodyPr wrap="square" lIns="0" tIns="0" rIns="0" bIns="0" rtlCol="0" anchor="t"/>
+          <a:lstStyle/>
+          <a:p>
+            <a:pPr indent="0" marL="0">
+              <a:buNone/>
+            </a:pPr>
+            <a:r>
+              <a:rPr lang="en-US" sz="900" dirty="0">
+                <a:solidFill>
+                  <a:srgbClr val="3A3A42"/>
+                </a:solidFill>
+                <a:latin typeface="Pretendard" pitchFamily="34" charset="0"/>
+                <a:ea typeface="Pretendard" pitchFamily="34" charset="-122"/>
+                <a:cs typeface="Pretendard" pitchFamily="34" charset="-120"/>
+              </a:rPr>
+              <a:t>더 정확한 매칭으로 원하는 상품을 빠르게 찾을 수 있습니다.</a:t>
+            </a:r>
+            <a:endParaRPr lang="en-US" sz="900" dirty="0"/>
+          </a:p>
+        </p:txBody>
+      </p:sp>
+      <p:pic>
+        <p:nvPicPr>
+          <p:cNvPr id="60" name="Image 11" descr="preencoded.png">    </p:cNvPr>
+          <p:cNvPicPr>
+            <a:picLocks noChangeAspect="1"/>
+          </p:cNvPicPr>
+          <p:nvPr/>
+        </p:nvPicPr>
+        <p:blipFill>
+          <a:blip r:embed="rId12"/>
+          <a:stretch>
+            <a:fillRect/>
+          </a:stretch>
+        </p:blipFill>
+        <p:spPr>
+          <a:xfrm>
             <a:off x="6035040" y="4526280"/>
             <a:ext cx="146304" cy="146304"/>
           </a:xfrm>
@@ -19123,7 +18929,7 @@
       </p:pic>
       <p:sp>
         <p:nvSpPr>
-          <p:cNvPr id="58" name="Text 45"/>
+          <p:cNvPr id="61" name="Text 47"/>
           <p:cNvSpPr txBox="1"/>
           <p:nvPr/>
         </p:nvSpPr>
@@ -19162,7 +18968,7 @@
       </p:sp>
       <p:sp>
         <p:nvSpPr>
-          <p:cNvPr id="59" name="Shape 46"/>
+          <p:cNvPr id="62" name="Shape 48"/>
           <p:cNvSpPr/>
           <p:nvPr/>
         </p:nvSpPr>
@@ -19189,7 +18995,7 @@
       </p:sp>
       <p:sp>
         <p:nvSpPr>
-          <p:cNvPr id="60" name="Text 47"/>
+          <p:cNvPr id="63" name="Text 49"/>
           <p:cNvSpPr txBox="1"/>
           <p:nvPr/>
         </p:nvSpPr>
@@ -19228,7 +19034,7 @@
       </p:sp>
       <p:sp>
         <p:nvSpPr>
-          <p:cNvPr id="61" name="Text 48"/>
+          <p:cNvPr id="64" name="Text 50"/>
           <p:cNvSpPr txBox="1"/>
           <p:nvPr/>
         </p:nvSpPr>
@@ -19267,7 +19073,7 @@
       </p:sp>
       <p:sp>
         <p:nvSpPr>
-          <p:cNvPr id="62" name="Shape 49"/>
+          <p:cNvPr id="65" name="Shape 51"/>
           <p:cNvSpPr/>
           <p:nvPr/>
         </p:nvSpPr>
@@ -19294,7 +19100,7 @@
       </p:sp>
       <p:sp>
         <p:nvSpPr>
-          <p:cNvPr id="63" name="Text 50"/>
+          <p:cNvPr id="66" name="Text 52"/>
           <p:cNvSpPr txBox="1"/>
           <p:nvPr/>
         </p:nvSpPr>
@@ -19333,7 +19139,7 @@
       </p:sp>
       <p:sp>
         <p:nvSpPr>
-          <p:cNvPr id="64" name="Shape 51"/>
+          <p:cNvPr id="67" name="Shape 53"/>
           <p:cNvSpPr/>
           <p:nvPr/>
         </p:nvSpPr>
@@ -19357,7 +19163,7 @@
       </p:sp>
       <p:sp>
         <p:nvSpPr>
-          <p:cNvPr id="65" name="Text 52"/>
+          <p:cNvPr id="68" name="Text 54"/>
           <p:cNvSpPr txBox="1"/>
           <p:nvPr/>
         </p:nvSpPr>
@@ -19396,7 +19202,7 @@
       </p:sp>
       <p:sp>
         <p:nvSpPr>
-          <p:cNvPr id="66" name="Text 53"/>
+          <p:cNvPr id="69" name="Text 55"/>
           <p:cNvSpPr txBox="1"/>
           <p:nvPr/>
         </p:nvSpPr>
@@ -19435,7 +19241,7 @@
       </p:sp>
       <p:sp>
         <p:nvSpPr>
-          <p:cNvPr id="67" name="Text 54"/>
+          <p:cNvPr id="70" name="Text 56"/>
           <p:cNvSpPr txBox="1"/>
           <p:nvPr/>
         </p:nvSpPr>
@@ -19477,7 +19283,7 @@
       </p:sp>
       <p:sp>
         <p:nvSpPr>
-          <p:cNvPr id="68" name="Shape 55"/>
+          <p:cNvPr id="71" name="Shape 57"/>
           <p:cNvSpPr/>
           <p:nvPr/>
         </p:nvSpPr>
@@ -19504,7 +19310,7 @@
       </p:sp>
       <p:sp>
         <p:nvSpPr>
-          <p:cNvPr id="69" name="Shape 56"/>
+          <p:cNvPr id="72" name="Shape 58"/>
           <p:cNvSpPr/>
           <p:nvPr/>
         </p:nvSpPr>
@@ -19529,14 +19335,14 @@
       </p:sp>
       <p:pic>
         <p:nvPicPr>
-          <p:cNvPr id="70" name="Image 11" descr="preencoded.png">    </p:cNvPr>
+          <p:cNvPr id="73" name="Image 12" descr="preencoded.png">    </p:cNvPr>
           <p:cNvPicPr>
             <a:picLocks noChangeAspect="1"/>
           </p:cNvPicPr>
           <p:nvPr/>
         </p:nvPicPr>
         <p:blipFill>
-          <a:blip r:embed="rId12"/>
+          <a:blip r:embed="rId13"/>
           <a:stretch>
             <a:fillRect/>
           </a:stretch>
@@ -19553,7 +19359,7 @@
       </p:pic>
       <p:sp>
         <p:nvSpPr>
-          <p:cNvPr id="71" name="Text 57"/>
+          <p:cNvPr id="74" name="Text 59"/>
           <p:cNvSpPr txBox="1"/>
           <p:nvPr/>
         </p:nvSpPr>

</xml_diff>